<commit_message>
Add 'think' option to JSON schema request and update project report and presentation
</commit_message>
<xml_diff>
--- a/report/Lumen_Project_Presentation.pptx
+++ b/report/Lumen_Project_Presentation.pptx
@@ -12,6 +12,7 @@
     <p:sldId id="260" r:id="rId11"/>
     <p:sldId id="261" r:id="rId12"/>
     <p:sldId id="262" r:id="rId13"/>
+    <p:sldId id="263" r:id="rId14"/>
   </p:sldIdLst>
   <p:sldSz cx="12191695" cy="6858000" type="screen4x3"/>
   <p:notesSz cx="6858000" cy="9144000"/>
@@ -3110,16 +3111,16 @@
         </p:nvSpPr>
         <p:spPr>
           <a:xfrm>
-            <a:off x="658368" y="502920"/>
-            <a:ext cx="10607040" cy="256032"/>
-          </a:xfrm>
-          <a:prstGeom prst="rect">
-            <a:avLst/>
-          </a:prstGeom>
-          <a:noFill/>
-        </p:spPr>
-        <p:txBody>
-          <a:bodyPr wrap="square" lIns="18288" rIns="18288" tIns="9144" bIns="9144">
+            <a:off x="640080" y="502920"/>
+            <a:ext cx="10881360" cy="228600"/>
+          </a:xfrm>
+          <a:prstGeom prst="rect">
+            <a:avLst/>
+          </a:prstGeom>
+          <a:noFill/>
+        </p:spPr>
+        <p:txBody>
+          <a:bodyPr wrap="square" lIns="36576" rIns="36576" tIns="18288" bIns="18288">
             <a:spAutoFit/>
           </a:bodyPr>
           <a:lstStyle/>
@@ -3133,7 +3134,7 @@
               </a:defRPr>
             </a:pPr>
             <a:r>
-              <a:t>PROJECT OVERVIEW  /  27 OCTOBER 2026</a:t>
+              <a:t>PROJECT OVERVIEW  /  5-MINUTE TALK  /  27 OCTOBER 2026</a:t>
             </a:r>
           </a:p>
         </p:txBody>
@@ -3146,22 +3147,22 @@
         </p:nvSpPr>
         <p:spPr>
           <a:xfrm>
-            <a:off x="658368" y="1115568"/>
-            <a:ext cx="4937760" cy="731520"/>
-          </a:xfrm>
-          <a:prstGeom prst="rect">
-            <a:avLst/>
-          </a:prstGeom>
-          <a:noFill/>
-        </p:spPr>
-        <p:txBody>
-          <a:bodyPr wrap="square" lIns="18288" rIns="18288" tIns="9144" bIns="9144">
+            <a:off x="640080" y="1005840"/>
+            <a:ext cx="4937760" cy="640080"/>
+          </a:xfrm>
+          <a:prstGeom prst="rect">
+            <a:avLst/>
+          </a:prstGeom>
+          <a:noFill/>
+        </p:spPr>
+        <p:txBody>
+          <a:bodyPr wrap="square" lIns="36576" rIns="36576" tIns="18288" bIns="18288">
             <a:spAutoFit/>
           </a:bodyPr>
           <a:lstStyle/>
           <a:p>
             <a:pPr>
-              <a:defRPr sz="4600" b="1">
+              <a:defRPr sz="4400" b="1">
                 <a:solidFill>
                   <a:srgbClr val="FFFFFF"/>
                 </a:solidFill>
@@ -3182,22 +3183,22 @@
         </p:nvSpPr>
         <p:spPr>
           <a:xfrm>
-            <a:off x="676656" y="1975104"/>
-            <a:ext cx="5029200" cy="713232"/>
-          </a:xfrm>
-          <a:prstGeom prst="rect">
-            <a:avLst/>
-          </a:prstGeom>
-          <a:noFill/>
-        </p:spPr>
-        <p:txBody>
-          <a:bodyPr wrap="square" lIns="18288" rIns="18288" tIns="9144" bIns="9144">
+            <a:off x="667512" y="1783080"/>
+            <a:ext cx="4892040" cy="841248"/>
+          </a:xfrm>
+          <a:prstGeom prst="rect">
+            <a:avLst/>
+          </a:prstGeom>
+          <a:noFill/>
+        </p:spPr>
+        <p:txBody>
+          <a:bodyPr wrap="square" lIns="36576" rIns="36576" tIns="18288" bIns="18288">
             <a:spAutoFit/>
           </a:bodyPr>
           <a:lstStyle/>
           <a:p>
             <a:pPr>
-              <a:defRPr sz="2200" b="0">
+              <a:defRPr sz="2300" b="0">
                 <a:solidFill>
                   <a:srgbClr val="DCEAE6"/>
                 </a:solidFill>
@@ -3205,7 +3206,7 @@
               </a:defRPr>
             </a:pPr>
             <a:r>
-              <a:t>A source-linked companion for pathology-report wording and care-team conversations</a:t>
+              <a:t>A source-linked companion for pathology-report conversations</a:t>
             </a:r>
           </a:p>
         </p:txBody>
@@ -3218,8 +3219,8 @@
         </p:nvSpPr>
         <p:spPr>
           <a:xfrm>
-            <a:off x="676656" y="2999232"/>
-            <a:ext cx="4389120" cy="484632"/>
+            <a:off x="685800" y="2834640"/>
+            <a:ext cx="4754880" cy="502920"/>
           </a:xfrm>
           <a:prstGeom prst="roundRect">
             <a:avLst/>
@@ -3263,16 +3264,16 @@
         </p:nvSpPr>
         <p:spPr>
           <a:xfrm>
-            <a:off x="822960" y="3145536"/>
-            <a:ext cx="4114800" cy="164592"/>
-          </a:xfrm>
-          <a:prstGeom prst="rect">
-            <a:avLst/>
-          </a:prstGeom>
-          <a:noFill/>
-        </p:spPr>
-        <p:txBody>
-          <a:bodyPr wrap="square" lIns="18288" rIns="18288" tIns="9144" bIns="9144">
+            <a:off x="850392" y="2999232"/>
+            <a:ext cx="4434840" cy="164592"/>
+          </a:xfrm>
+          <a:prstGeom prst="rect">
+            <a:avLst/>
+          </a:prstGeom>
+          <a:noFill/>
+        </p:spPr>
+        <p:txBody>
+          <a:bodyPr wrap="square" lIns="36576" rIns="36576" tIns="18288" bIns="18288">
             <a:spAutoFit/>
           </a:bodyPr>
           <a:lstStyle/>
@@ -3293,7 +3294,7 @@
       </p:sp>
       <p:pic>
         <p:nvPicPr>
-          <p:cNvPr id="7" name="Picture 6" descr="patient_journey.png"/>
+          <p:cNvPr id="7" name="Picture 6" descr="experience_map.png"/>
           <p:cNvPicPr>
             <a:picLocks noChangeAspect="1"/>
           </p:cNvPicPr>
@@ -3307,8 +3308,8 @@
         </p:blipFill>
         <p:spPr>
           <a:xfrm>
-            <a:off x="5532120" y="1298448"/>
-            <a:ext cx="5989320" cy="1801368"/>
+            <a:off x="5715000" y="1234440"/>
+            <a:ext cx="5852160" cy="2103120"/>
           </a:xfrm>
           <a:prstGeom prst="rect">
             <a:avLst/>
@@ -3317,28 +3318,109 @@
       </p:pic>
       <p:sp>
         <p:nvSpPr>
-          <p:cNvPr id="8" name="TextBox 7"/>
-          <p:cNvSpPr txBox="1"/>
-          <p:nvPr/>
-        </p:nvSpPr>
-        <p:spPr>
-          <a:xfrm>
-            <a:off x="694944" y="4645152"/>
-            <a:ext cx="10515600" cy="676656"/>
-          </a:xfrm>
-          <a:prstGeom prst="rect">
-            <a:avLst/>
-          </a:prstGeom>
-          <a:noFill/>
-        </p:spPr>
-        <p:txBody>
-          <a:bodyPr wrap="square" lIns="18288" rIns="18288" tIns="9144" bIns="9144">
+          <p:cNvPr id="8" name="Rounded Rectangle 7"/>
+          <p:cNvSpPr/>
+          <p:nvPr/>
+        </p:nvSpPr>
+        <p:spPr>
+          <a:xfrm>
+            <a:off x="685800" y="3886200"/>
+            <a:ext cx="10835640" cy="1298448"/>
+          </a:xfrm>
+          <a:prstGeom prst="roundRect">
+            <a:avLst/>
+          </a:prstGeom>
+          <a:solidFill>
+            <a:srgbClr val="254A4D"/>
+          </a:solidFill>
+          <a:ln w="12700">
+            <a:solidFill>
+              <a:srgbClr val="254A4D"/>
+            </a:solidFill>
+          </a:ln>
+        </p:spPr>
+        <p:style>
+          <a:lnRef idx="1">
+            <a:schemeClr val="accent1"/>
+          </a:lnRef>
+          <a:fillRef idx="3">
+            <a:schemeClr val="accent1"/>
+          </a:fillRef>
+          <a:effectRef idx="2">
+            <a:schemeClr val="accent1"/>
+          </a:effectRef>
+          <a:fontRef idx="minor">
+            <a:schemeClr val="lt1"/>
+          </a:fontRef>
+        </p:style>
+        <p:txBody>
+          <a:bodyPr rtlCol="0" anchor="ctr"/>
+          <a:lstStyle/>
+          <a:p>
+            <a:pPr algn="ctr"/>
+          </a:p>
+        </p:txBody>
+      </p:sp>
+      <p:sp>
+        <p:nvSpPr>
+          <p:cNvPr id="9" name="TextBox 8"/>
+          <p:cNvSpPr txBox="1"/>
+          <p:nvPr/>
+        </p:nvSpPr>
+        <p:spPr>
+          <a:xfrm>
+            <a:off x="914400" y="4160520"/>
+            <a:ext cx="10332720" cy="731520"/>
+          </a:xfrm>
+          <a:prstGeom prst="rect">
+            <a:avLst/>
+          </a:prstGeom>
+          <a:noFill/>
+        </p:spPr>
+        <p:txBody>
+          <a:bodyPr wrap="square" lIns="36576" rIns="36576" tIns="18288" bIns="18288">
             <a:spAutoFit/>
           </a:bodyPr>
           <a:lstStyle/>
           <a:p>
             <a:pPr>
-              <a:defRPr sz="1600" b="1">
+              <a:defRPr sz="1900" b="1">
+                <a:solidFill>
+                  <a:srgbClr val="FFFFFF"/>
+                </a:solidFill>
+                <a:latin typeface="Aptos"/>
+              </a:defRPr>
+            </a:pPr>
+            <a:r>
+              <a:t>Designed to keep exact source wording visible and support neutral care-team questions. It is a software prototype - not a clinical product.</a:t>
+            </a:r>
+          </a:p>
+        </p:txBody>
+      </p:sp>
+      <p:sp>
+        <p:nvSpPr>
+          <p:cNvPr id="10" name="TextBox 9"/>
+          <p:cNvSpPr txBox="1"/>
+          <p:nvPr/>
+        </p:nvSpPr>
+        <p:spPr>
+          <a:xfrm>
+            <a:off x="713232" y="5623560"/>
+            <a:ext cx="10789920" cy="502920"/>
+          </a:xfrm>
+          <a:prstGeom prst="rect">
+            <a:avLst/>
+          </a:prstGeom>
+          <a:noFill/>
+        </p:spPr>
+        <p:txBody>
+          <a:bodyPr wrap="square" lIns="36576" rIns="36576" tIns="18288" bIns="18288">
+            <a:spAutoFit/>
+          </a:bodyPr>
+          <a:lstStyle/>
+          <a:p>
+            <a:pPr>
+              <a:defRPr sz="1300" b="1">
                 <a:solidFill>
                   <a:srgbClr val="F2D9A8"/>
                 </a:solidFill>
@@ -3346,29 +3428,29 @@
               </a:defRPr>
             </a:pPr>
             <a:r>
-              <a:t>A software prototype, not a clinical product. No live model output, clinician review, or patient outcome evaluation has been completed.</a:t>
-            </a:r>
-          </a:p>
-        </p:txBody>
-      </p:sp>
-      <p:sp>
-        <p:nvSpPr>
-          <p:cNvPr id="9" name="TextBox 8"/>
+              <a:t>No live model output • No clinician review • No clinical validation • Not for patient use</a:t>
+            </a:r>
+          </a:p>
+        </p:txBody>
+      </p:sp>
+      <p:sp>
+        <p:nvSpPr>
+          <p:cNvPr id="11" name="TextBox 10"/>
           <p:cNvSpPr txBox="1"/>
           <p:nvPr/>
         </p:nvSpPr>
         <p:spPr>
           <a:xfrm>
             <a:off x="502920" y="6510528"/>
-            <a:ext cx="9601200" cy="164592"/>
-          </a:xfrm>
-          <a:prstGeom prst="rect">
-            <a:avLst/>
-          </a:prstGeom>
-          <a:noFill/>
-        </p:spPr>
-        <p:txBody>
-          <a:bodyPr wrap="square" lIns="18288" rIns="18288" tIns="9144" bIns="9144">
+            <a:ext cx="9692640" cy="164592"/>
+          </a:xfrm>
+          <a:prstGeom prst="rect">
+            <a:avLst/>
+          </a:prstGeom>
+          <a:noFill/>
+        </p:spPr>
+        <p:txBody>
+          <a:bodyPr wrap="square" lIns="36576" rIns="36576" tIns="18288" bIns="18288">
             <a:spAutoFit/>
           </a:bodyPr>
           <a:lstStyle/>
@@ -3382,14 +3464,14 @@
               </a:defRPr>
             </a:pPr>
             <a:r>
-              <a:t>SYNTHETIC-ONLY  |  MODEL DISABLED  |  NOT FOR CLINICAL DECISIONS</a:t>
-            </a:r>
-          </a:p>
-        </p:txBody>
-      </p:sp>
-      <p:sp>
-        <p:nvSpPr>
-          <p:cNvPr id="10" name="TextBox 9"/>
+              <a:t>SYNTHETIC-ONLY  |  MODEL OFF  |  NOT FOR CLINICAL DECISIONS</a:t>
+            </a:r>
+          </a:p>
+        </p:txBody>
+      </p:sp>
+      <p:sp>
+        <p:nvSpPr>
+          <p:cNvPr id="12" name="TextBox 11"/>
           <p:cNvSpPr txBox="1"/>
           <p:nvPr/>
         </p:nvSpPr>
@@ -3404,7 +3486,7 @@
           <a:noFill/>
         </p:spPr>
         <p:txBody>
-          <a:bodyPr wrap="square" lIns="18288" rIns="18288" tIns="9144" bIns="9144">
+          <a:bodyPr wrap="square" lIns="36576" rIns="36576" tIns="18288" bIns="18288">
             <a:spAutoFit/>
           </a:bodyPr>
           <a:lstStyle/>
@@ -3466,7 +3548,7 @@
           <a:noFill/>
         </p:spPr>
         <p:txBody>
-          <a:bodyPr wrap="square" lIns="18288" rIns="18288" tIns="9144" bIns="9144">
+          <a:bodyPr wrap="square" lIns="36576" rIns="36576" tIns="18288" bIns="18288">
             <a:spAutoFit/>
           </a:bodyPr>
           <a:lstStyle/>
@@ -3480,7 +3562,7 @@
               </a:defRPr>
             </a:pPr>
             <a:r>
-              <a:t>01 / PATIENT EXPERIENCE</a:t>
+              <a:t>01 / CONTEXT AND PATIENT EXPERIENCE</a:t>
             </a:r>
           </a:p>
         </p:txBody>
@@ -3493,7 +3575,7 @@
         </p:nvSpPr>
         <p:spPr>
           <a:xfrm>
-            <a:off x="530352" y="630936"/>
+            <a:off x="530352" y="621792"/>
             <a:ext cx="11064240" cy="457200"/>
           </a:xfrm>
           <a:prstGeom prst="rect">
@@ -3502,13 +3584,13 @@
           <a:noFill/>
         </p:spPr>
         <p:txBody>
-          <a:bodyPr wrap="square" lIns="18288" rIns="18288" tIns="9144" bIns="9144">
+          <a:bodyPr wrap="square" lIns="36576" rIns="36576" tIns="18288" bIns="18288">
             <a:spAutoFit/>
           </a:bodyPr>
           <a:lstStyle/>
           <a:p>
             <a:pPr>
-              <a:defRPr sz="2700" b="1">
+              <a:defRPr sz="2600" b="1">
                 <a:solidFill>
                   <a:srgbClr val="18383E"/>
                 </a:solidFill>
@@ -3516,7 +3598,7 @@
               </a:defRPr>
             </a:pPr>
             <a:r>
-              <a:t>Keep the source in view</a:t>
+              <a:t>From technical wording to a grounded conversation</a:t>
             </a:r>
           </a:p>
         </p:txBody>
@@ -3529,22 +3611,22 @@
         </p:nvSpPr>
         <p:spPr>
           <a:xfrm>
-            <a:off x="530352" y="1133856"/>
-            <a:ext cx="10972800" cy="438912"/>
-          </a:xfrm>
-          <a:prstGeom prst="rect">
-            <a:avLst/>
-          </a:prstGeom>
-          <a:noFill/>
-        </p:spPr>
-        <p:txBody>
-          <a:bodyPr wrap="square" lIns="18288" rIns="18288" tIns="9144" bIns="9144">
+            <a:off x="530352" y="1115568"/>
+            <a:ext cx="10972800" cy="457200"/>
+          </a:xfrm>
+          <a:prstGeom prst="rect">
+            <a:avLst/>
+          </a:prstGeom>
+          <a:noFill/>
+        </p:spPr>
+        <p:txBody>
+          <a:bodyPr wrap="square" lIns="36576" rIns="36576" tIns="18288" bIns="18288">
             <a:spAutoFit/>
           </a:bodyPr>
           <a:lstStyle/>
           <a:p>
             <a:pPr>
-              <a:defRPr sz="1300" b="0">
+              <a:defRPr sz="1200" b="0">
                 <a:solidFill>
                   <a:srgbClr val="4B6268"/>
                 </a:solidFill>
@@ -3552,7 +3634,7 @@
               </a:defRPr>
             </a:pPr>
             <a:r>
-              <a:t>Designed to turn report wording into a better-supported conversation - not a care decision.</a:t>
+              <a:t>A design hypothesis: source-linked explanations may help prepare questions; impact has not been evaluated.</a:t>
             </a:r>
           </a:p>
         </p:txBody>
@@ -3566,15 +3648,15 @@
         <p:spPr>
           <a:xfrm>
             <a:off x="502920" y="6510528"/>
-            <a:ext cx="9601200" cy="164592"/>
-          </a:xfrm>
-          <a:prstGeom prst="rect">
-            <a:avLst/>
-          </a:prstGeom>
-          <a:noFill/>
-        </p:spPr>
-        <p:txBody>
-          <a:bodyPr wrap="square" lIns="18288" rIns="18288" tIns="9144" bIns="9144">
+            <a:ext cx="9692640" cy="164592"/>
+          </a:xfrm>
+          <a:prstGeom prst="rect">
+            <a:avLst/>
+          </a:prstGeom>
+          <a:noFill/>
+        </p:spPr>
+        <p:txBody>
+          <a:bodyPr wrap="square" lIns="36576" rIns="36576" tIns="18288" bIns="18288">
             <a:spAutoFit/>
           </a:bodyPr>
           <a:lstStyle/>
@@ -3588,7 +3670,7 @@
               </a:defRPr>
             </a:pPr>
             <a:r>
-              <a:t>SYNTHETIC-ONLY  |  MODEL DISABLED  |  NOT FOR CLINICAL DECISIONS</a:t>
+              <a:t>SYNTHETIC-ONLY  |  MODEL OFF  |  NOT FOR CLINICAL DECISIONS</a:t>
             </a:r>
           </a:p>
         </p:txBody>
@@ -3610,7 +3692,7 @@
           <a:noFill/>
         </p:spPr>
         <p:txBody>
-          <a:bodyPr wrap="square" lIns="18288" rIns="18288" tIns="9144" bIns="9144">
+          <a:bodyPr wrap="square" lIns="36576" rIns="36576" tIns="18288" bIns="18288">
             <a:spAutoFit/>
           </a:bodyPr>
           <a:lstStyle/>
@@ -3631,7 +3713,7 @@
       </p:sp>
       <p:pic>
         <p:nvPicPr>
-          <p:cNvPr id="7" name="Picture 6" descr="patient_journey.png"/>
+          <p:cNvPr id="7" name="Picture 6" descr="experience_map.png"/>
           <p:cNvPicPr>
             <a:picLocks noChangeAspect="1"/>
           </p:cNvPicPr>
@@ -3645,8 +3727,8 @@
         </p:blipFill>
         <p:spPr>
           <a:xfrm>
-            <a:off x="594360" y="1828800"/>
-            <a:ext cx="10972800" cy="3291840"/>
+            <a:off x="585216" y="1719072"/>
+            <a:ext cx="11018520" cy="3941063"/>
           </a:xfrm>
           <a:prstGeom prst="rect">
             <a:avLst/>
@@ -3661,18 +3743,18 @@
         </p:nvSpPr>
         <p:spPr>
           <a:xfrm>
-            <a:off x="685800" y="5394960"/>
-            <a:ext cx="5257800" cy="713232"/>
+            <a:off x="713232" y="5760720"/>
+            <a:ext cx="10744200" cy="502920"/>
           </a:xfrm>
           <a:prstGeom prst="roundRect">
             <a:avLst/>
           </a:prstGeom>
           <a:solidFill>
-            <a:srgbClr val="FFFFFF"/>
+            <a:srgbClr val="FFF5E3"/>
           </a:solidFill>
           <a:ln w="12700">
             <a:solidFill>
-              <a:srgbClr val="D9E3DF"/>
+              <a:srgbClr val="EBD7AD"/>
             </a:solidFill>
           </a:ln>
         </p:spPr>
@@ -3706,22 +3788,22 @@
         </p:nvSpPr>
         <p:spPr>
           <a:xfrm>
-            <a:off x="896112" y="5532120"/>
-            <a:ext cx="4846320" cy="411480"/>
-          </a:xfrm>
-          <a:prstGeom prst="rect">
-            <a:avLst/>
-          </a:prstGeom>
-          <a:noFill/>
-        </p:spPr>
-        <p:txBody>
-          <a:bodyPr wrap="square" lIns="18288" rIns="18288" tIns="9144" bIns="9144">
+            <a:off x="914400" y="5870448"/>
+            <a:ext cx="10332720" cy="256032"/>
+          </a:xfrm>
+          <a:prstGeom prst="rect">
+            <a:avLst/>
+          </a:prstGeom>
+          <a:noFill/>
+        </p:spPr>
+        <p:txBody>
+          <a:bodyPr wrap="square" lIns="36576" rIns="36576" tIns="18288" bIns="18288">
             <a:spAutoFit/>
           </a:bodyPr>
           <a:lstStyle/>
           <a:p>
             <a:pPr>
-              <a:defRPr sz="1400" b="1">
+              <a:defRPr sz="1300" b="1">
                 <a:solidFill>
                   <a:srgbClr val="18383E"/>
                 </a:solidFill>
@@ -3729,88 +3811,7 @@
               </a:defRPr>
             </a:pPr>
             <a:r>
-              <a:t>Exact source quotes • missing facts stay ‘not stated’ • neutral care-team questions</a:t>
-            </a:r>
-          </a:p>
-        </p:txBody>
-      </p:sp>
-      <p:sp>
-        <p:nvSpPr>
-          <p:cNvPr id="10" name="Rounded Rectangle 9"/>
-          <p:cNvSpPr/>
-          <p:nvPr/>
-        </p:nvSpPr>
-        <p:spPr>
-          <a:xfrm>
-            <a:off x="6172200" y="5394960"/>
-            <a:ext cx="5285232" cy="713232"/>
-          </a:xfrm>
-          <a:prstGeom prst="roundRect">
-            <a:avLst/>
-          </a:prstGeom>
-          <a:solidFill>
-            <a:srgbClr val="FFF5E3"/>
-          </a:solidFill>
-          <a:ln w="12700">
-            <a:solidFill>
-              <a:srgbClr val="EBD7AD"/>
-            </a:solidFill>
-          </a:ln>
-        </p:spPr>
-        <p:style>
-          <a:lnRef idx="1">
-            <a:schemeClr val="accent1"/>
-          </a:lnRef>
-          <a:fillRef idx="3">
-            <a:schemeClr val="accent1"/>
-          </a:fillRef>
-          <a:effectRef idx="2">
-            <a:schemeClr val="accent1"/>
-          </a:effectRef>
-          <a:fontRef idx="minor">
-            <a:schemeClr val="lt1"/>
-          </a:fontRef>
-        </p:style>
-        <p:txBody>
-          <a:bodyPr rtlCol="0" anchor="ctr"/>
-          <a:lstStyle/>
-          <a:p>
-            <a:pPr algn="ctr"/>
-          </a:p>
-        </p:txBody>
-      </p:sp>
-      <p:sp>
-        <p:nvSpPr>
-          <p:cNvPr id="11" name="TextBox 10"/>
-          <p:cNvSpPr txBox="1"/>
-          <p:nvPr/>
-        </p:nvSpPr>
-        <p:spPr>
-          <a:xfrm>
-            <a:off x="6382512" y="5532120"/>
-            <a:ext cx="4800600" cy="411480"/>
-          </a:xfrm>
-          <a:prstGeom prst="rect">
-            <a:avLst/>
-          </a:prstGeom>
-          <a:noFill/>
-        </p:spPr>
-        <p:txBody>
-          <a:bodyPr wrap="square" lIns="18288" rIns="18288" tIns="9144" bIns="9144">
-            <a:spAutoFit/>
-          </a:bodyPr>
-          <a:lstStyle/>
-          <a:p>
-            <a:pPr>
-              <a:defRPr sz="1400" b="1">
-                <a:solidFill>
-                  <a:srgbClr val="18383E"/>
-                </a:solidFill>
-                <a:latin typeface="Aptos"/>
-              </a:defRPr>
-            </a:pPr>
-            <a:r>
-              <a:t>English text only • no uploads/OCR • no diagnosis or treatment advice</a:t>
+              <a:t>No diagnosis, prognosis, treatment selection, dosing, trial eligibility or urgent-symptom triage.</a:t>
             </a:r>
           </a:p>
         </p:txBody>
@@ -3858,7 +3859,7 @@
           <a:noFill/>
         </p:spPr>
         <p:txBody>
-          <a:bodyPr wrap="square" lIns="18288" rIns="18288" tIns="9144" bIns="9144">
+          <a:bodyPr wrap="square" lIns="36576" rIns="36576" tIns="18288" bIns="18288">
             <a:spAutoFit/>
           </a:bodyPr>
           <a:lstStyle/>
@@ -3872,7 +3873,7 @@
               </a:defRPr>
             </a:pPr>
             <a:r>
-              <a:t>02 / TRUST AND DATA FLOW</a:t>
+              <a:t>02 / PRODUCT EXPERIENCE</a:t>
             </a:r>
           </a:p>
         </p:txBody>
@@ -3885,7 +3886,7 @@
         </p:nvSpPr>
         <p:spPr>
           <a:xfrm>
-            <a:off x="530352" y="630936"/>
+            <a:off x="530352" y="621792"/>
             <a:ext cx="11064240" cy="457200"/>
           </a:xfrm>
           <a:prstGeom prst="rect">
@@ -3894,13 +3895,13 @@
           <a:noFill/>
         </p:spPr>
         <p:txBody>
-          <a:bodyPr wrap="square" lIns="18288" rIns="18288" tIns="9144" bIns="9144">
+          <a:bodyPr wrap="square" lIns="36576" rIns="36576" tIns="18288" bIns="18288">
             <a:spAutoFit/>
           </a:bodyPr>
           <a:lstStyle/>
           <a:p>
             <a:pPr>
-              <a:defRPr sz="2700" b="1">
+              <a:defRPr sz="2600" b="1">
                 <a:solidFill>
                   <a:srgbClr val="18383E"/>
                 </a:solidFill>
@@ -3908,7 +3909,7 @@
               </a:defRPr>
             </a:pPr>
             <a:r>
-              <a:t>A bounded path with explicit limits</a:t>
+              <a:t>Evidence first; safe stop states included</a:t>
             </a:r>
           </a:p>
         </p:txBody>
@@ -3921,22 +3922,22 @@
         </p:nvSpPr>
         <p:spPr>
           <a:xfrm>
-            <a:off x="530352" y="1133856"/>
-            <a:ext cx="10972800" cy="438912"/>
-          </a:xfrm>
-          <a:prstGeom prst="rect">
-            <a:avLst/>
-          </a:prstGeom>
-          <a:noFill/>
-        </p:spPr>
-        <p:txBody>
-          <a:bodyPr wrap="square" lIns="18288" rIns="18288" tIns="9144" bIns="9144">
+            <a:off x="530352" y="1115568"/>
+            <a:ext cx="10972800" cy="457200"/>
+          </a:xfrm>
+          <a:prstGeom prst="rect">
+            <a:avLst/>
+          </a:prstGeom>
+          <a:noFill/>
+        </p:spPr>
+        <p:txBody>
+          <a:bodyPr wrap="square" lIns="36576" rIns="36576" tIns="18288" bIns="18288">
             <a:spAutoFit/>
           </a:bodyPr>
           <a:lstStyle/>
           <a:p>
             <a:pPr>
-              <a:defRPr sz="1300" b="0">
+              <a:defRPr sz="1200" b="0">
                 <a:solidFill>
                   <a:srgbClr val="4B6268"/>
                 </a:solidFill>
@@ -3944,7 +3945,7 @@
               </a:defRPr>
             </a:pPr>
             <a:r>
-              <a:t>High-level flow: browser to same-origin service route to evidence/safety checks and a result or abstention.</a:t>
+              <a:t>A fictional source excerpt illustrates the evidence interaction - not a live AI result.</a:t>
             </a:r>
           </a:p>
         </p:txBody>
@@ -3958,15 +3959,15 @@
         <p:spPr>
           <a:xfrm>
             <a:off x="502920" y="6510528"/>
-            <a:ext cx="9601200" cy="164592"/>
-          </a:xfrm>
-          <a:prstGeom prst="rect">
-            <a:avLst/>
-          </a:prstGeom>
-          <a:noFill/>
-        </p:spPr>
-        <p:txBody>
-          <a:bodyPr wrap="square" lIns="18288" rIns="18288" tIns="9144" bIns="9144">
+            <a:ext cx="9692640" cy="164592"/>
+          </a:xfrm>
+          <a:prstGeom prst="rect">
+            <a:avLst/>
+          </a:prstGeom>
+          <a:noFill/>
+        </p:spPr>
+        <p:txBody>
+          <a:bodyPr wrap="square" lIns="36576" rIns="36576" tIns="18288" bIns="18288">
             <a:spAutoFit/>
           </a:bodyPr>
           <a:lstStyle/>
@@ -3980,7 +3981,7 @@
               </a:defRPr>
             </a:pPr>
             <a:r>
-              <a:t>SYNTHETIC-ONLY  |  MODEL DISABLED  |  NOT FOR CLINICAL DECISIONS</a:t>
+              <a:t>SYNTHETIC-ONLY  |  MODEL OFF  |  NOT FOR CLINICAL DECISIONS</a:t>
             </a:r>
           </a:p>
         </p:txBody>
@@ -4002,7 +4003,7 @@
           <a:noFill/>
         </p:spPr>
         <p:txBody>
-          <a:bodyPr wrap="square" lIns="18288" rIns="18288" tIns="9144" bIns="9144">
+          <a:bodyPr wrap="square" lIns="36576" rIns="36576" tIns="18288" bIns="18288">
             <a:spAutoFit/>
           </a:bodyPr>
           <a:lstStyle/>
@@ -4023,7 +4024,7 @@
       </p:sp>
       <p:pic>
         <p:nvPicPr>
-          <p:cNvPr id="7" name="Picture 6" descr="information_flow.png"/>
+          <p:cNvPr id="7" name="Picture 6" descr="evidence_gate.png"/>
           <p:cNvPicPr>
             <a:picLocks noChangeAspect="1"/>
           </p:cNvPicPr>
@@ -4037,8 +4038,8 @@
         </p:blipFill>
         <p:spPr>
           <a:xfrm>
-            <a:off x="658368" y="1691640"/>
-            <a:ext cx="10881360" cy="3904487"/>
+            <a:off x="658368" y="1719072"/>
+            <a:ext cx="10808208" cy="3246120"/>
           </a:xfrm>
           <a:prstGeom prst="rect">
             <a:avLst/>
@@ -4047,22 +4048,103 @@
       </p:pic>
       <p:sp>
         <p:nvSpPr>
-          <p:cNvPr id="8" name="TextBox 7"/>
-          <p:cNvSpPr txBox="1"/>
-          <p:nvPr/>
-        </p:nvSpPr>
-        <p:spPr>
-          <a:xfrm>
-            <a:off x="731520" y="5742432"/>
-            <a:ext cx="10789920" cy="384048"/>
-          </a:xfrm>
-          <a:prstGeom prst="rect">
-            <a:avLst/>
-          </a:prstGeom>
-          <a:noFill/>
-        </p:spPr>
-        <p:txBody>
-          <a:bodyPr wrap="square" lIns="18288" rIns="18288" tIns="9144" bIns="9144">
+          <p:cNvPr id="8" name="Rounded Rectangle 7"/>
+          <p:cNvSpPr/>
+          <p:nvPr/>
+        </p:nvSpPr>
+        <p:spPr>
+          <a:xfrm>
+            <a:off x="713232" y="5166360"/>
+            <a:ext cx="5285232" cy="1024128"/>
+          </a:xfrm>
+          <a:prstGeom prst="roundRect">
+            <a:avLst/>
+          </a:prstGeom>
+          <a:solidFill>
+            <a:srgbClr val="FFFFFF"/>
+          </a:solidFill>
+          <a:ln w="12700">
+            <a:solidFill>
+              <a:srgbClr val="D9E3DF"/>
+            </a:solidFill>
+          </a:ln>
+        </p:spPr>
+        <p:style>
+          <a:lnRef idx="1">
+            <a:schemeClr val="accent1"/>
+          </a:lnRef>
+          <a:fillRef idx="3">
+            <a:schemeClr val="accent1"/>
+          </a:fillRef>
+          <a:effectRef idx="2">
+            <a:schemeClr val="accent1"/>
+          </a:effectRef>
+          <a:fontRef idx="minor">
+            <a:schemeClr val="lt1"/>
+          </a:fontRef>
+        </p:style>
+        <p:txBody>
+          <a:bodyPr rtlCol="0" anchor="ctr"/>
+          <a:lstStyle/>
+          <a:p>
+            <a:pPr algn="ctr"/>
+          </a:p>
+        </p:txBody>
+      </p:sp>
+      <p:sp>
+        <p:nvSpPr>
+          <p:cNvPr id="9" name="TextBox 8"/>
+          <p:cNvSpPr txBox="1"/>
+          <p:nvPr/>
+        </p:nvSpPr>
+        <p:spPr>
+          <a:xfrm>
+            <a:off x="914400" y="5321808"/>
+            <a:ext cx="4846320" cy="201168"/>
+          </a:xfrm>
+          <a:prstGeom prst="rect">
+            <a:avLst/>
+          </a:prstGeom>
+          <a:noFill/>
+        </p:spPr>
+        <p:txBody>
+          <a:bodyPr wrap="square" lIns="36576" rIns="36576" tIns="18288" bIns="18288">
+            <a:spAutoFit/>
+          </a:bodyPr>
+          <a:lstStyle/>
+          <a:p>
+            <a:pPr>
+              <a:defRPr sz="900" b="1">
+                <a:solidFill>
+                  <a:srgbClr val="2E7D74"/>
+                </a:solidFill>
+                <a:latin typeface="Aptos"/>
+              </a:defRPr>
+            </a:pPr>
+            <a:r>
+              <a:t>SYNTHETIC SOURCE EXCERPT</a:t>
+            </a:r>
+          </a:p>
+        </p:txBody>
+      </p:sp>
+      <p:sp>
+        <p:nvSpPr>
+          <p:cNvPr id="10" name="TextBox 9"/>
+          <p:cNvSpPr txBox="1"/>
+          <p:nvPr/>
+        </p:nvSpPr>
+        <p:spPr>
+          <a:xfrm>
+            <a:off x="914400" y="5614416"/>
+            <a:ext cx="4846320" cy="384048"/>
+          </a:xfrm>
+          <a:prstGeom prst="rect">
+            <a:avLst/>
+          </a:prstGeom>
+          <a:noFill/>
+        </p:spPr>
+        <p:txBody>
+          <a:bodyPr wrap="square" lIns="36576" rIns="36576" tIns="18288" bIns="18288">
             <a:spAutoFit/>
           </a:bodyPr>
           <a:lstStyle/>
@@ -4070,13 +4152,130 @@
             <a:pPr>
               <a:defRPr sz="1200" b="1">
                 <a:solidFill>
-                  <a:srgbClr val="BE6B58"/>
-                </a:solidFill>
-                <a:latin typeface="Aptos"/>
-              </a:defRPr>
-            </a:pPr>
-            <a:r>
-              <a:t>The current provider-disabled path returns no claims. If a provider is enabled later, text may be processed externally; terms and retention need review.</a:t>
+                  <a:srgbClr val="18383E"/>
+                </a:solidFill>
+                <a:latin typeface="Aptos"/>
+              </a:defRPr>
+            </a:pPr>
+            <a:r>
+              <a:t>Lung, right upper lobe, biopsy: Adenocarcinoma, acinar pattern.</a:t>
+            </a:r>
+          </a:p>
+        </p:txBody>
+      </p:sp>
+      <p:sp>
+        <p:nvSpPr>
+          <p:cNvPr id="11" name="Rounded Rectangle 10"/>
+          <p:cNvSpPr/>
+          <p:nvPr/>
+        </p:nvSpPr>
+        <p:spPr>
+          <a:xfrm>
+            <a:off x="6199632" y="5166360"/>
+            <a:ext cx="5248656" cy="1024128"/>
+          </a:xfrm>
+          <a:prstGeom prst="roundRect">
+            <a:avLst/>
+          </a:prstGeom>
+          <a:solidFill>
+            <a:srgbClr val="FFF5E3"/>
+          </a:solidFill>
+          <a:ln w="12700">
+            <a:solidFill>
+              <a:srgbClr val="EBD7AD"/>
+            </a:solidFill>
+          </a:ln>
+        </p:spPr>
+        <p:style>
+          <a:lnRef idx="1">
+            <a:schemeClr val="accent1"/>
+          </a:lnRef>
+          <a:fillRef idx="3">
+            <a:schemeClr val="accent1"/>
+          </a:fillRef>
+          <a:effectRef idx="2">
+            <a:schemeClr val="accent1"/>
+          </a:effectRef>
+          <a:fontRef idx="minor">
+            <a:schemeClr val="lt1"/>
+          </a:fontRef>
+        </p:style>
+        <p:txBody>
+          <a:bodyPr rtlCol="0" anchor="ctr"/>
+          <a:lstStyle/>
+          <a:p>
+            <a:pPr algn="ctr"/>
+          </a:p>
+        </p:txBody>
+      </p:sp>
+      <p:sp>
+        <p:nvSpPr>
+          <p:cNvPr id="12" name="TextBox 11"/>
+          <p:cNvSpPr txBox="1"/>
+          <p:nvPr/>
+        </p:nvSpPr>
+        <p:spPr>
+          <a:xfrm>
+            <a:off x="6400800" y="5321808"/>
+            <a:ext cx="4800600" cy="201168"/>
+          </a:xfrm>
+          <a:prstGeom prst="rect">
+            <a:avLst/>
+          </a:prstGeom>
+          <a:noFill/>
+        </p:spPr>
+        <p:txBody>
+          <a:bodyPr wrap="square" lIns="36576" rIns="36576" tIns="18288" bIns="18288">
+            <a:spAutoFit/>
+          </a:bodyPr>
+          <a:lstStyle/>
+          <a:p>
+            <a:pPr>
+              <a:defRPr sz="900" b="1">
+                <a:solidFill>
+                  <a:srgbClr val="9E6B1E"/>
+                </a:solidFill>
+                <a:latin typeface="Aptos"/>
+              </a:defRPr>
+            </a:pPr>
+            <a:r>
+              <a:t>CURRENT DEMO STATUS</a:t>
+            </a:r>
+          </a:p>
+        </p:txBody>
+      </p:sp>
+      <p:sp>
+        <p:nvSpPr>
+          <p:cNvPr id="13" name="TextBox 12"/>
+          <p:cNvSpPr txBox="1"/>
+          <p:nvPr/>
+        </p:nvSpPr>
+        <p:spPr>
+          <a:xfrm>
+            <a:off x="6400800" y="5596128"/>
+            <a:ext cx="4800600" cy="411480"/>
+          </a:xfrm>
+          <a:prstGeom prst="rect">
+            <a:avLst/>
+          </a:prstGeom>
+          <a:noFill/>
+        </p:spPr>
+        <p:txBody>
+          <a:bodyPr wrap="square" lIns="36576" rIns="36576" tIns="18288" bIns="18288">
+            <a:spAutoFit/>
+          </a:bodyPr>
+          <a:lstStyle/>
+          <a:p>
+            <a:pPr>
+              <a:defRPr sz="1100" b="1">
+                <a:solidFill>
+                  <a:srgbClr val="18383E"/>
+                </a:solidFill>
+                <a:latin typeface="Aptos"/>
+              </a:defRPr>
+            </a:pPr>
+            <a:r>
+              <a:t>Provider disabled: live path returns unavailable with no claims. Positive state is a deterministic test fixture.</a:t>
             </a:r>
           </a:p>
         </p:txBody>
@@ -4124,7 +4323,7 @@
           <a:noFill/>
         </p:spPr>
         <p:txBody>
-          <a:bodyPr wrap="square" lIns="18288" rIns="18288" tIns="9144" bIns="9144">
+          <a:bodyPr wrap="square" lIns="36576" rIns="36576" tIns="18288" bIns="18288">
             <a:spAutoFit/>
           </a:bodyPr>
           <a:lstStyle/>
@@ -4138,7 +4337,7 @@
               </a:defRPr>
             </a:pPr>
             <a:r>
-              <a:t>03 / EVIDENCE GATE</a:t>
+              <a:t>03 / INFORMATION FLOW</a:t>
             </a:r>
           </a:p>
         </p:txBody>
@@ -4151,7 +4350,7 @@
         </p:nvSpPr>
         <p:spPr>
           <a:xfrm>
-            <a:off x="530352" y="630936"/>
+            <a:off x="530352" y="621792"/>
             <a:ext cx="11064240" cy="457200"/>
           </a:xfrm>
           <a:prstGeom prst="rect">
@@ -4160,13 +4359,13 @@
           <a:noFill/>
         </p:spPr>
         <p:txBody>
-          <a:bodyPr wrap="square" lIns="18288" rIns="18288" tIns="9144" bIns="9144">
+          <a:bodyPr wrap="square" lIns="36576" rIns="36576" tIns="18288" bIns="18288">
             <a:spAutoFit/>
           </a:bodyPr>
           <a:lstStyle/>
           <a:p>
             <a:pPr>
-              <a:defRPr sz="2700" b="1">
+              <a:defRPr sz="2600" b="1">
                 <a:solidFill>
                   <a:srgbClr val="18383E"/>
                 </a:solidFill>
@@ -4174,7 +4373,7 @@
               </a:defRPr>
             </a:pPr>
             <a:r>
-              <a:t>Unsupported wording should not pass through</a:t>
+              <a:t>A bounded path, with an explicit provider boundary</a:t>
             </a:r>
           </a:p>
         </p:txBody>
@@ -4187,22 +4386,22 @@
         </p:nvSpPr>
         <p:spPr>
           <a:xfrm>
-            <a:off x="530352" y="1133856"/>
-            <a:ext cx="10972800" cy="438912"/>
-          </a:xfrm>
-          <a:prstGeom prst="rect">
-            <a:avLst/>
-          </a:prstGeom>
-          <a:noFill/>
-        </p:spPr>
-        <p:txBody>
-          <a:bodyPr wrap="square" lIns="18288" rIns="18288" tIns="9144" bIns="9144">
+            <a:off x="530352" y="1115568"/>
+            <a:ext cx="10972800" cy="457200"/>
+          </a:xfrm>
+          <a:prstGeom prst="rect">
+            <a:avLst/>
+          </a:prstGeom>
+          <a:noFill/>
+        </p:spPr>
+        <p:txBody>
+          <a:bodyPr wrap="square" lIns="36576" rIns="36576" tIns="18288" bIns="18288">
             <a:spAutoFit/>
           </a:bodyPr>
           <a:lstStyle/>
           <a:p>
             <a:pPr>
-              <a:defRPr sz="1300" b="0">
+              <a:defRPr sz="1200" b="0">
                 <a:solidFill>
                   <a:srgbClr val="4B6268"/>
                 </a:solidFill>
@@ -4210,7 +4409,7 @@
               </a:defRPr>
             </a:pPr>
             <a:r>
-              <a:t>The intended result path links each displayed statement to source text; live model behavior has not been evaluated.</a:t>
+              <a:t>High-level product architecture; this is not a deployment or compliance certification.</a:t>
             </a:r>
           </a:p>
         </p:txBody>
@@ -4224,15 +4423,15 @@
         <p:spPr>
           <a:xfrm>
             <a:off x="502920" y="6510528"/>
-            <a:ext cx="9601200" cy="164592"/>
-          </a:xfrm>
-          <a:prstGeom prst="rect">
-            <a:avLst/>
-          </a:prstGeom>
-          <a:noFill/>
-        </p:spPr>
-        <p:txBody>
-          <a:bodyPr wrap="square" lIns="18288" rIns="18288" tIns="9144" bIns="9144">
+            <a:ext cx="9692640" cy="164592"/>
+          </a:xfrm>
+          <a:prstGeom prst="rect">
+            <a:avLst/>
+          </a:prstGeom>
+          <a:noFill/>
+        </p:spPr>
+        <p:txBody>
+          <a:bodyPr wrap="square" lIns="36576" rIns="36576" tIns="18288" bIns="18288">
             <a:spAutoFit/>
           </a:bodyPr>
           <a:lstStyle/>
@@ -4246,7 +4445,7 @@
               </a:defRPr>
             </a:pPr>
             <a:r>
-              <a:t>SYNTHETIC-ONLY  |  MODEL DISABLED  |  NOT FOR CLINICAL DECISIONS</a:t>
+              <a:t>SYNTHETIC-ONLY  |  MODEL OFF  |  NOT FOR CLINICAL DECISIONS</a:t>
             </a:r>
           </a:p>
         </p:txBody>
@@ -4268,7 +4467,7 @@
           <a:noFill/>
         </p:spPr>
         <p:txBody>
-          <a:bodyPr wrap="square" lIns="18288" rIns="18288" tIns="9144" bIns="9144">
+          <a:bodyPr wrap="square" lIns="36576" rIns="36576" tIns="18288" bIns="18288">
             <a:spAutoFit/>
           </a:bodyPr>
           <a:lstStyle/>
@@ -4289,7 +4488,7 @@
       </p:sp>
       <p:pic>
         <p:nvPicPr>
-          <p:cNvPr id="7" name="Picture 6" descr="evidence_gate.png"/>
+          <p:cNvPr id="7" name="Picture 6" descr="data_boundary.png"/>
           <p:cNvPicPr>
             <a:picLocks noChangeAspect="1"/>
           </p:cNvPicPr>
@@ -4303,8 +4502,8 @@
         </p:blipFill>
         <p:spPr>
           <a:xfrm>
-            <a:off x="640080" y="1828800"/>
-            <a:ext cx="10927080" cy="3182112"/>
+            <a:off x="621792" y="1700784"/>
+            <a:ext cx="10945368" cy="3922776"/>
           </a:xfrm>
           <a:prstGeom prst="rect">
             <a:avLst/>
@@ -4313,36 +4512,81 @@
       </p:pic>
       <p:sp>
         <p:nvSpPr>
-          <p:cNvPr id="8" name="TextBox 7"/>
-          <p:cNvSpPr txBox="1"/>
-          <p:nvPr/>
-        </p:nvSpPr>
-        <p:spPr>
-          <a:xfrm>
-            <a:off x="749808" y="5394960"/>
-            <a:ext cx="10698480" cy="475488"/>
-          </a:xfrm>
-          <a:prstGeom prst="rect">
-            <a:avLst/>
-          </a:prstGeom>
-          <a:noFill/>
-        </p:spPr>
-        <p:txBody>
-          <a:bodyPr wrap="square" lIns="18288" rIns="18288" tIns="9144" bIns="9144">
+          <p:cNvPr id="8" name="Rounded Rectangle 7"/>
+          <p:cNvSpPr/>
+          <p:nvPr/>
+        </p:nvSpPr>
+        <p:spPr>
+          <a:xfrm>
+            <a:off x="713232" y="5760720"/>
+            <a:ext cx="10744200" cy="502920"/>
+          </a:xfrm>
+          <a:prstGeom prst="roundRect">
+            <a:avLst/>
+          </a:prstGeom>
+          <a:solidFill>
+            <a:srgbClr val="FFFFFF"/>
+          </a:solidFill>
+          <a:ln w="12700">
+            <a:solidFill>
+              <a:srgbClr val="D9E3DF"/>
+            </a:solidFill>
+          </a:ln>
+        </p:spPr>
+        <p:style>
+          <a:lnRef idx="1">
+            <a:schemeClr val="accent1"/>
+          </a:lnRef>
+          <a:fillRef idx="3">
+            <a:schemeClr val="accent1"/>
+          </a:fillRef>
+          <a:effectRef idx="2">
+            <a:schemeClr val="accent1"/>
+          </a:effectRef>
+          <a:fontRef idx="minor">
+            <a:schemeClr val="lt1"/>
+          </a:fontRef>
+        </p:style>
+        <p:txBody>
+          <a:bodyPr rtlCol="0" anchor="ctr"/>
+          <a:lstStyle/>
+          <a:p>
+            <a:pPr algn="ctr"/>
+          </a:p>
+        </p:txBody>
+      </p:sp>
+      <p:sp>
+        <p:nvSpPr>
+          <p:cNvPr id="9" name="TextBox 8"/>
+          <p:cNvSpPr txBox="1"/>
+          <p:nvPr/>
+        </p:nvSpPr>
+        <p:spPr>
+          <a:xfrm>
+            <a:off x="914400" y="5870448"/>
+            <a:ext cx="10332720" cy="256032"/>
+          </a:xfrm>
+          <a:prstGeom prst="rect">
+            <a:avLst/>
+          </a:prstGeom>
+          <a:noFill/>
+        </p:spPr>
+        <p:txBody>
+          <a:bodyPr wrap="square" lIns="36576" rIns="36576" tIns="18288" bIns="18288">
             <a:spAutoFit/>
           </a:bodyPr>
           <a:lstStyle/>
           <a:p>
             <a:pPr>
-              <a:defRPr sz="1300" b="1">
-                <a:solidFill>
-                  <a:srgbClr val="BE6B58"/>
-                </a:solidFill>
-                <a:latin typeface="Aptos"/>
-              </a:defRPr>
-            </a:pPr>
-            <a:r>
-              <a:t>A matching quote is necessary, not proof of semantic or clinical correctness. The provider remains disabled in this demo.</a:t>
+              <a:defRPr sz="1200" b="1">
+                <a:solidFill>
+                  <a:srgbClr val="18383E"/>
+                </a:solidFill>
+                <a:latin typeface="Aptos"/>
+              </a:defRPr>
+            </a:pPr>
+            <a:r>
+              <a:t>No report database or browser storage/URL persistence; if enabled later, external provider processing needs review.</a:t>
             </a:r>
           </a:p>
         </p:txBody>
@@ -4390,7 +4634,7 @@
           <a:noFill/>
         </p:spPr>
         <p:txBody>
-          <a:bodyPr wrap="square" lIns="18288" rIns="18288" tIns="9144" bIns="9144">
+          <a:bodyPr wrap="square" lIns="36576" rIns="36576" tIns="18288" bIns="18288">
             <a:spAutoFit/>
           </a:bodyPr>
           <a:lstStyle/>
@@ -4404,7 +4648,7 @@
               </a:defRPr>
             </a:pPr>
             <a:r>
-              <a:t>04 / WHAT WE VERIFIED</a:t>
+              <a:t>04 / SAFETY AND PRIVACY</a:t>
             </a:r>
           </a:p>
         </p:txBody>
@@ -4417,7 +4661,7 @@
         </p:nvSpPr>
         <p:spPr>
           <a:xfrm>
-            <a:off x="530352" y="630936"/>
+            <a:off x="530352" y="621792"/>
             <a:ext cx="11064240" cy="457200"/>
           </a:xfrm>
           <a:prstGeom prst="rect">
@@ -4426,13 +4670,13 @@
           <a:noFill/>
         </p:spPr>
         <p:txBody>
-          <a:bodyPr wrap="square" lIns="18288" rIns="18288" tIns="9144" bIns="9144">
+          <a:bodyPr wrap="square" lIns="36576" rIns="36576" tIns="18288" bIns="18288">
             <a:spAutoFit/>
           </a:bodyPr>
           <a:lstStyle/>
           <a:p>
             <a:pPr>
-              <a:defRPr sz="2700" b="1">
+              <a:defRPr sz="2600" b="1">
                 <a:solidFill>
                   <a:srgbClr val="18383E"/>
                 </a:solidFill>
@@ -4440,7 +4684,7 @@
               </a:defRPr>
             </a:pPr>
             <a:r>
-              <a:t>Software checks are not clinical proof</a:t>
+              <a:t>Controls reduce software risk; they do not prove clinical safety</a:t>
             </a:r>
           </a:p>
         </p:txBody>
@@ -4453,22 +4697,22 @@
         </p:nvSpPr>
         <p:spPr>
           <a:xfrm>
-            <a:off x="530352" y="1133856"/>
-            <a:ext cx="10972800" cy="438912"/>
-          </a:xfrm>
-          <a:prstGeom prst="rect">
-            <a:avLst/>
-          </a:prstGeom>
-          <a:noFill/>
-        </p:spPr>
-        <p:txBody>
-          <a:bodyPr wrap="square" lIns="18288" rIns="18288" tIns="9144" bIns="9144">
+            <a:off x="530352" y="1115568"/>
+            <a:ext cx="10972800" cy="457200"/>
+          </a:xfrm>
+          <a:prstGeom prst="rect">
+            <a:avLst/>
+          </a:prstGeom>
+          <a:noFill/>
+        </p:spPr>
+        <p:txBody>
+          <a:bodyPr wrap="square" lIns="36576" rIns="36576" tIns="18288" bIns="18288">
             <a:spAutoFit/>
           </a:bodyPr>
           <a:lstStyle/>
           <a:p>
             <a:pPr>
-              <a:defRPr sz="1300" b="0">
+              <a:defRPr sz="1200" b="0">
                 <a:solidFill>
                   <a:srgbClr val="4B6268"/>
                 </a:solidFill>
@@ -4476,7 +4720,7 @@
               </a:defRPr>
             </a:pPr>
             <a:r>
-              <a:t>Counts below are reproducible software/fixture evidence only; they do not measure model quality or patient impact.</a:t>
+              <a:t>No external provider was called. The app is limited to synthetic/de-identified excerpts in this prototype.</a:t>
             </a:r>
           </a:p>
         </p:txBody>
@@ -4490,15 +4734,15 @@
         <p:spPr>
           <a:xfrm>
             <a:off x="502920" y="6510528"/>
-            <a:ext cx="9601200" cy="164592"/>
-          </a:xfrm>
-          <a:prstGeom prst="rect">
-            <a:avLst/>
-          </a:prstGeom>
-          <a:noFill/>
-        </p:spPr>
-        <p:txBody>
-          <a:bodyPr wrap="square" lIns="18288" rIns="18288" tIns="9144" bIns="9144">
+            <a:ext cx="9692640" cy="164592"/>
+          </a:xfrm>
+          <a:prstGeom prst="rect">
+            <a:avLst/>
+          </a:prstGeom>
+          <a:noFill/>
+        </p:spPr>
+        <p:txBody>
+          <a:bodyPr wrap="square" lIns="36576" rIns="36576" tIns="18288" bIns="18288">
             <a:spAutoFit/>
           </a:bodyPr>
           <a:lstStyle/>
@@ -4512,7 +4756,7 @@
               </a:defRPr>
             </a:pPr>
             <a:r>
-              <a:t>SYNTHETIC-ONLY  |  MODEL DISABLED  |  NOT FOR CLINICAL DECISIONS</a:t>
+              <a:t>SYNTHETIC-ONLY  |  MODEL OFF  |  NOT FOR CLINICAL DECISIONS</a:t>
             </a:r>
           </a:p>
         </p:txBody>
@@ -4534,7 +4778,7 @@
           <a:noFill/>
         </p:spPr>
         <p:txBody>
-          <a:bodyPr wrap="square" lIns="18288" rIns="18288" tIns="9144" bIns="9144">
+          <a:bodyPr wrap="square" lIns="36576" rIns="36576" tIns="18288" bIns="18288">
             <a:spAutoFit/>
           </a:bodyPr>
           <a:lstStyle/>
@@ -4553,40 +4797,16 @@
           </a:p>
         </p:txBody>
       </p:sp>
-      <p:pic>
-        <p:nvPicPr>
-          <p:cNvPr id="7" name="Picture 6" descr="validation_snapshot.png"/>
-          <p:cNvPicPr>
-            <a:picLocks noChangeAspect="1"/>
-          </p:cNvPicPr>
-          <p:nvPr/>
-        </p:nvPicPr>
-        <p:blipFill>
-          <a:blip r:embed="rId2"/>
-          <a:stretch>
-            <a:fillRect/>
-          </a:stretch>
-        </p:blipFill>
-        <p:spPr>
-          <a:xfrm>
-            <a:off x="621792" y="1755648"/>
-            <a:ext cx="10972800" cy="2743200"/>
-          </a:xfrm>
-          <a:prstGeom prst="rect">
-            <a:avLst/>
-          </a:prstGeom>
-        </p:spPr>
-      </p:pic>
-      <p:sp>
-        <p:nvSpPr>
-          <p:cNvPr id="8" name="Rounded Rectangle 7"/>
+      <p:sp>
+        <p:nvSpPr>
+          <p:cNvPr id="7" name="Rounded Rectangle 6"/>
           <p:cNvSpPr/>
           <p:nvPr/>
         </p:nvSpPr>
         <p:spPr>
           <a:xfrm>
-            <a:off x="713232" y="4718304"/>
-            <a:ext cx="5212080" cy="987552"/>
+            <a:off x="676656" y="1874519"/>
+            <a:ext cx="5266944" cy="1389888"/>
           </a:xfrm>
           <a:prstGeom prst="roundRect">
             <a:avLst/>
@@ -4624,28 +4844,64 @@
       </p:sp>
       <p:sp>
         <p:nvSpPr>
+          <p:cNvPr id="8" name="TextBox 7"/>
+          <p:cNvSpPr txBox="1"/>
+          <p:nvPr/>
+        </p:nvSpPr>
+        <p:spPr>
+          <a:xfrm>
+            <a:off x="877824" y="2075688"/>
+            <a:ext cx="4800600" cy="246888"/>
+          </a:xfrm>
+          <a:prstGeom prst="rect">
+            <a:avLst/>
+          </a:prstGeom>
+          <a:noFill/>
+        </p:spPr>
+        <p:txBody>
+          <a:bodyPr wrap="square" lIns="36576" rIns="36576" tIns="18288" bIns="18288">
+            <a:spAutoFit/>
+          </a:bodyPr>
+          <a:lstStyle/>
+          <a:p>
+            <a:pPr>
+              <a:defRPr sz="1300" b="1">
+                <a:solidFill>
+                  <a:srgbClr val="2E7D74"/>
+                </a:solidFill>
+                <a:latin typeface="Aptos"/>
+              </a:defRPr>
+            </a:pPr>
+            <a:r>
+              <a:t>SOURCE CHECKS</a:t>
+            </a:r>
+          </a:p>
+        </p:txBody>
+      </p:sp>
+      <p:sp>
+        <p:nvSpPr>
           <p:cNvPr id="9" name="TextBox 8"/>
           <p:cNvSpPr txBox="1"/>
           <p:nvPr/>
         </p:nvSpPr>
         <p:spPr>
           <a:xfrm>
-            <a:off x="914400" y="4882896"/>
-            <a:ext cx="4828032" cy="658368"/>
-          </a:xfrm>
-          <a:prstGeom prst="rect">
-            <a:avLst/>
-          </a:prstGeom>
-          <a:noFill/>
-        </p:spPr>
-        <p:txBody>
-          <a:bodyPr wrap="square" lIns="18288" rIns="18288" tIns="9144" bIns="9144">
+            <a:off x="877824" y="2468879"/>
+            <a:ext cx="4773168" cy="594360"/>
+          </a:xfrm>
+          <a:prstGeom prst="rect">
+            <a:avLst/>
+          </a:prstGeom>
+          <a:noFill/>
+        </p:spPr>
+        <p:txBody>
+          <a:bodyPr wrap="square" lIns="36576" rIns="36576" tIns="18288" bIns="18288">
             <a:spAutoFit/>
           </a:bodyPr>
           <a:lstStyle/>
           <a:p>
             <a:pPr>
-              <a:defRPr sz="1400" b="1">
+              <a:defRPr sz="1400" b="0">
                 <a:solidFill>
                   <a:srgbClr val="18383E"/>
                 </a:solidFill>
@@ -4653,7 +4909,7 @@
               </a:defRPr>
             </a:pPr>
             <a:r>
-              <a:t>Measured: 64 backend tests, 10 browser flows, 0 axe violations in tested states, 34/34 exact gold fixture spans.</a:t>
+              <a:t>Exact quote and offsets are checked against the submitted text.</a:t>
             </a:r>
           </a:p>
         </p:txBody>
@@ -4666,18 +4922,18 @@
         </p:nvSpPr>
         <p:spPr>
           <a:xfrm>
-            <a:off x="6199632" y="4718304"/>
-            <a:ext cx="5212080" cy="987552"/>
+            <a:off x="6272784" y="1874519"/>
+            <a:ext cx="5266944" cy="1389888"/>
           </a:xfrm>
           <a:prstGeom prst="roundRect">
             <a:avLst/>
           </a:prstGeom>
           <a:solidFill>
-            <a:srgbClr val="F9EAE6"/>
+            <a:srgbClr val="FFFFFF"/>
           </a:solidFill>
           <a:ln w="12700">
             <a:solidFill>
-              <a:srgbClr val="E7C8C0"/>
+              <a:srgbClr val="D9E3DF"/>
             </a:solidFill>
           </a:ln>
         </p:spPr>
@@ -4711,22 +4967,58 @@
         </p:nvSpPr>
         <p:spPr>
           <a:xfrm>
-            <a:off x="6400800" y="4882896"/>
-            <a:ext cx="4800600" cy="658368"/>
-          </a:xfrm>
-          <a:prstGeom prst="rect">
-            <a:avLst/>
-          </a:prstGeom>
-          <a:noFill/>
-        </p:spPr>
-        <p:txBody>
-          <a:bodyPr wrap="square" lIns="18288" rIns="18288" tIns="9144" bIns="9144">
+            <a:off x="6473952" y="2075688"/>
+            <a:ext cx="4800600" cy="246888"/>
+          </a:xfrm>
+          <a:prstGeom prst="rect">
+            <a:avLst/>
+          </a:prstGeom>
+          <a:noFill/>
+        </p:spPr>
+        <p:txBody>
+          <a:bodyPr wrap="square" lIns="36576" rIns="36576" tIns="18288" bIns="18288">
             <a:spAutoFit/>
           </a:bodyPr>
           <a:lstStyle/>
           <a:p>
             <a:pPr>
-              <a:defRPr sz="1400" b="1">
+              <a:defRPr sz="1300" b="1">
+                <a:solidFill>
+                  <a:srgbClr val="2E7D74"/>
+                </a:solidFill>
+                <a:latin typeface="Aptos"/>
+              </a:defRPr>
+            </a:pPr>
+            <a:r>
+              <a:t>VERIFY + ABSTAIN</a:t>
+            </a:r>
+          </a:p>
+        </p:txBody>
+      </p:sp>
+      <p:sp>
+        <p:nvSpPr>
+          <p:cNvPr id="12" name="TextBox 11"/>
+          <p:cNvSpPr txBox="1"/>
+          <p:nvPr/>
+        </p:nvSpPr>
+        <p:spPr>
+          <a:xfrm>
+            <a:off x="6473952" y="2468879"/>
+            <a:ext cx="4773168" cy="594360"/>
+          </a:xfrm>
+          <a:prstGeom prst="rect">
+            <a:avLst/>
+          </a:prstGeom>
+          <a:noFill/>
+        </p:spPr>
+        <p:txBody>
+          <a:bodyPr wrap="square" lIns="36576" rIns="36576" tIns="18288" bIns="18288">
+            <a:spAutoFit/>
+          </a:bodyPr>
+          <a:lstStyle/>
+          <a:p>
+            <a:pPr>
+              <a:defRPr sz="1400" b="0">
                 <a:solidFill>
                   <a:srgbClr val="18383E"/>
                 </a:solidFill>
@@ -4734,7 +5026,322 @@
               </a:defRPr>
             </a:pPr>
             <a:r>
-              <a:t>Not measured: model accuracy, unsupported-claim rate, clinical correctness, latency, or outcomes.</a:t>
+              <a:t>Separate verification; unsupported or malformed output is withheld.</a:t>
+            </a:r>
+          </a:p>
+        </p:txBody>
+      </p:sp>
+      <p:sp>
+        <p:nvSpPr>
+          <p:cNvPr id="13" name="Rounded Rectangle 12"/>
+          <p:cNvSpPr/>
+          <p:nvPr/>
+        </p:nvSpPr>
+        <p:spPr>
+          <a:xfrm>
+            <a:off x="676656" y="3520439"/>
+            <a:ext cx="5266944" cy="1389888"/>
+          </a:xfrm>
+          <a:prstGeom prst="roundRect">
+            <a:avLst/>
+          </a:prstGeom>
+          <a:solidFill>
+            <a:srgbClr val="FFFFFF"/>
+          </a:solidFill>
+          <a:ln w="12700">
+            <a:solidFill>
+              <a:srgbClr val="D9E3DF"/>
+            </a:solidFill>
+          </a:ln>
+        </p:spPr>
+        <p:style>
+          <a:lnRef idx="1">
+            <a:schemeClr val="accent1"/>
+          </a:lnRef>
+          <a:fillRef idx="3">
+            <a:schemeClr val="accent1"/>
+          </a:fillRef>
+          <a:effectRef idx="2">
+            <a:schemeClr val="accent1"/>
+          </a:effectRef>
+          <a:fontRef idx="minor">
+            <a:schemeClr val="lt1"/>
+          </a:fontRef>
+        </p:style>
+        <p:txBody>
+          <a:bodyPr rtlCol="0" anchor="ctr"/>
+          <a:lstStyle/>
+          <a:p>
+            <a:pPr algn="ctr"/>
+          </a:p>
+        </p:txBody>
+      </p:sp>
+      <p:sp>
+        <p:nvSpPr>
+          <p:cNvPr id="14" name="TextBox 13"/>
+          <p:cNvSpPr txBox="1"/>
+          <p:nvPr/>
+        </p:nvSpPr>
+        <p:spPr>
+          <a:xfrm>
+            <a:off x="877824" y="3721607"/>
+            <a:ext cx="4800600" cy="246888"/>
+          </a:xfrm>
+          <a:prstGeom prst="rect">
+            <a:avLst/>
+          </a:prstGeom>
+          <a:noFill/>
+        </p:spPr>
+        <p:txBody>
+          <a:bodyPr wrap="square" lIns="36576" rIns="36576" tIns="18288" bIns="18288">
+            <a:spAutoFit/>
+          </a:bodyPr>
+          <a:lstStyle/>
+          <a:p>
+            <a:pPr>
+              <a:defRPr sz="1300" b="1">
+                <a:solidFill>
+                  <a:srgbClr val="BE6B58"/>
+                </a:solidFill>
+                <a:latin typeface="Aptos"/>
+              </a:defRPr>
+            </a:pPr>
+            <a:r>
+              <a:t>SCOPE REFUSALS</a:t>
+            </a:r>
+          </a:p>
+        </p:txBody>
+      </p:sp>
+      <p:sp>
+        <p:nvSpPr>
+          <p:cNvPr id="15" name="TextBox 14"/>
+          <p:cNvSpPr txBox="1"/>
+          <p:nvPr/>
+        </p:nvSpPr>
+        <p:spPr>
+          <a:xfrm>
+            <a:off x="877824" y="4114800"/>
+            <a:ext cx="4773168" cy="594360"/>
+          </a:xfrm>
+          <a:prstGeom prst="rect">
+            <a:avLst/>
+          </a:prstGeom>
+          <a:noFill/>
+        </p:spPr>
+        <p:txBody>
+          <a:bodyPr wrap="square" lIns="36576" rIns="36576" tIns="18288" bIns="18288">
+            <a:spAutoFit/>
+          </a:bodyPr>
+          <a:lstStyle/>
+          <a:p>
+            <a:pPr>
+              <a:defRPr sz="1400" b="0">
+                <a:solidFill>
+                  <a:srgbClr val="18383E"/>
+                </a:solidFill>
+                <a:latin typeface="Aptos"/>
+              </a:defRPr>
+            </a:pPr>
+            <a:r>
+              <a:t>Fixed boundaries for diagnosis, prognosis, treatment, dose, trials and urgent triage.</a:t>
+            </a:r>
+          </a:p>
+        </p:txBody>
+      </p:sp>
+      <p:sp>
+        <p:nvSpPr>
+          <p:cNvPr id="16" name="Rounded Rectangle 15"/>
+          <p:cNvSpPr/>
+          <p:nvPr/>
+        </p:nvSpPr>
+        <p:spPr>
+          <a:xfrm>
+            <a:off x="6272784" y="3520439"/>
+            <a:ext cx="5266944" cy="1389888"/>
+          </a:xfrm>
+          <a:prstGeom prst="roundRect">
+            <a:avLst/>
+          </a:prstGeom>
+          <a:solidFill>
+            <a:srgbClr val="FFFFFF"/>
+          </a:solidFill>
+          <a:ln w="12700">
+            <a:solidFill>
+              <a:srgbClr val="D9E3DF"/>
+            </a:solidFill>
+          </a:ln>
+        </p:spPr>
+        <p:style>
+          <a:lnRef idx="1">
+            <a:schemeClr val="accent1"/>
+          </a:lnRef>
+          <a:fillRef idx="3">
+            <a:schemeClr val="accent1"/>
+          </a:fillRef>
+          <a:effectRef idx="2">
+            <a:schemeClr val="accent1"/>
+          </a:effectRef>
+          <a:fontRef idx="minor">
+            <a:schemeClr val="lt1"/>
+          </a:fontRef>
+        </p:style>
+        <p:txBody>
+          <a:bodyPr rtlCol="0" anchor="ctr"/>
+          <a:lstStyle/>
+          <a:p>
+            <a:pPr algn="ctr"/>
+          </a:p>
+        </p:txBody>
+      </p:sp>
+      <p:sp>
+        <p:nvSpPr>
+          <p:cNvPr id="17" name="TextBox 16"/>
+          <p:cNvSpPr txBox="1"/>
+          <p:nvPr/>
+        </p:nvSpPr>
+        <p:spPr>
+          <a:xfrm>
+            <a:off x="6473952" y="3721607"/>
+            <a:ext cx="4800600" cy="246888"/>
+          </a:xfrm>
+          <a:prstGeom prst="rect">
+            <a:avLst/>
+          </a:prstGeom>
+          <a:noFill/>
+        </p:spPr>
+        <p:txBody>
+          <a:bodyPr wrap="square" lIns="36576" rIns="36576" tIns="18288" bIns="18288">
+            <a:spAutoFit/>
+          </a:bodyPr>
+          <a:lstStyle/>
+          <a:p>
+            <a:pPr>
+              <a:defRPr sz="1300" b="1">
+                <a:solidFill>
+                  <a:srgbClr val="BE6B58"/>
+                </a:solidFill>
+                <a:latin typeface="Aptos"/>
+              </a:defRPr>
+            </a:pPr>
+            <a:r>
+              <a:t>DATA DISCLOSURE</a:t>
+            </a:r>
+          </a:p>
+        </p:txBody>
+      </p:sp>
+      <p:sp>
+        <p:nvSpPr>
+          <p:cNvPr id="18" name="TextBox 17"/>
+          <p:cNvSpPr txBox="1"/>
+          <p:nvPr/>
+        </p:nvSpPr>
+        <p:spPr>
+          <a:xfrm>
+            <a:off x="6473952" y="4114800"/>
+            <a:ext cx="4773168" cy="594360"/>
+          </a:xfrm>
+          <a:prstGeom prst="rect">
+            <a:avLst/>
+          </a:prstGeom>
+          <a:noFill/>
+        </p:spPr>
+        <p:txBody>
+          <a:bodyPr wrap="square" lIns="36576" rIns="36576" tIns="18288" bIns="18288">
+            <a:spAutoFit/>
+          </a:bodyPr>
+          <a:lstStyle/>
+          <a:p>
+            <a:pPr>
+              <a:defRPr sz="1400" b="0">
+                <a:solidFill>
+                  <a:srgbClr val="18383E"/>
+                </a:solidFill>
+                <a:latin typeface="Aptos"/>
+              </a:defRPr>
+            </a:pPr>
+            <a:r>
+              <a:t>Provider disabled now; if enabled, text may be processed externally; terms/retention unreviewed.</a:t>
+            </a:r>
+          </a:p>
+        </p:txBody>
+      </p:sp>
+      <p:sp>
+        <p:nvSpPr>
+          <p:cNvPr id="19" name="Rounded Rectangle 18"/>
+          <p:cNvSpPr/>
+          <p:nvPr/>
+        </p:nvSpPr>
+        <p:spPr>
+          <a:xfrm>
+            <a:off x="676656" y="5321808"/>
+            <a:ext cx="10863072" cy="566928"/>
+          </a:xfrm>
+          <a:prstGeom prst="roundRect">
+            <a:avLst/>
+          </a:prstGeom>
+          <a:solidFill>
+            <a:srgbClr val="18383E"/>
+          </a:solidFill>
+          <a:ln w="12700">
+            <a:solidFill>
+              <a:srgbClr val="18383E"/>
+            </a:solidFill>
+          </a:ln>
+        </p:spPr>
+        <p:style>
+          <a:lnRef idx="1">
+            <a:schemeClr val="accent1"/>
+          </a:lnRef>
+          <a:fillRef idx="3">
+            <a:schemeClr val="accent1"/>
+          </a:fillRef>
+          <a:effectRef idx="2">
+            <a:schemeClr val="accent1"/>
+          </a:effectRef>
+          <a:fontRef idx="minor">
+            <a:schemeClr val="lt1"/>
+          </a:fontRef>
+        </p:style>
+        <p:txBody>
+          <a:bodyPr rtlCol="0" anchor="ctr"/>
+          <a:lstStyle/>
+          <a:p>
+            <a:pPr algn="ctr"/>
+          </a:p>
+        </p:txBody>
+      </p:sp>
+      <p:sp>
+        <p:nvSpPr>
+          <p:cNvPr id="20" name="TextBox 19"/>
+          <p:cNvSpPr txBox="1"/>
+          <p:nvPr/>
+        </p:nvSpPr>
+        <p:spPr>
+          <a:xfrm>
+            <a:off x="886968" y="5468112"/>
+            <a:ext cx="10442448" cy="274320"/>
+          </a:xfrm>
+          <a:prstGeom prst="rect">
+            <a:avLst/>
+          </a:prstGeom>
+          <a:noFill/>
+        </p:spPr>
+        <p:txBody>
+          <a:bodyPr wrap="square" lIns="36576" rIns="36576" tIns="18288" bIns="18288">
+            <a:spAutoFit/>
+          </a:bodyPr>
+          <a:lstStyle/>
+          <a:p>
+            <a:pPr>
+              <a:defRPr sz="1200" b="1">
+                <a:solidFill>
+                  <a:srgbClr val="FFFFFF"/>
+                </a:solidFill>
+                <a:latin typeface="Aptos"/>
+              </a:defRPr>
+            </a:pPr>
+            <a:r>
+              <a:t>Prompt-injection tests and fail-closed behavior are software checks, not a guarantee against every attack.</a:t>
             </a:r>
           </a:p>
         </p:txBody>
@@ -4782,7 +5389,7 @@
           <a:noFill/>
         </p:spPr>
         <p:txBody>
-          <a:bodyPr wrap="square" lIns="18288" rIns="18288" tIns="9144" bIns="9144">
+          <a:bodyPr wrap="square" lIns="36576" rIns="36576" tIns="18288" bIns="18288">
             <a:spAutoFit/>
           </a:bodyPr>
           <a:lstStyle/>
@@ -4796,7 +5403,7 @@
               </a:defRPr>
             </a:pPr>
             <a:r>
-              <a:t>05 / POTENTIAL IMPACT AND FEASIBILITY</a:t>
+              <a:t>05 / EVIDENCE AND EVALUATION</a:t>
             </a:r>
           </a:p>
         </p:txBody>
@@ -4809,7 +5416,7 @@
         </p:nvSpPr>
         <p:spPr>
           <a:xfrm>
-            <a:off x="530352" y="630936"/>
+            <a:off x="530352" y="621792"/>
             <a:ext cx="11064240" cy="457200"/>
           </a:xfrm>
           <a:prstGeom prst="rect">
@@ -4818,13 +5425,13 @@
           <a:noFill/>
         </p:spPr>
         <p:txBody>
-          <a:bodyPr wrap="square" lIns="18288" rIns="18288" tIns="9144" bIns="9144">
+          <a:bodyPr wrap="square" lIns="36576" rIns="36576" tIns="18288" bIns="18288">
             <a:spAutoFit/>
           </a:bodyPr>
           <a:lstStyle/>
           <a:p>
             <a:pPr>
-              <a:defRPr sz="2700" b="1">
+              <a:defRPr sz="2600" b="1">
                 <a:solidFill>
                   <a:srgbClr val="18383E"/>
                 </a:solidFill>
@@ -4832,7 +5439,7 @@
               </a:defRPr>
             </a:pPr>
             <a:r>
-              <a:t>A useful hypothesis - not a proven outcome</a:t>
+              <a:t>What is measured - and what is not</a:t>
             </a:r>
           </a:p>
         </p:txBody>
@@ -4845,22 +5452,22 @@
         </p:nvSpPr>
         <p:spPr>
           <a:xfrm>
-            <a:off x="530352" y="1133856"/>
-            <a:ext cx="10972800" cy="438912"/>
-          </a:xfrm>
-          <a:prstGeom prst="rect">
-            <a:avLst/>
-          </a:prstGeom>
-          <a:noFill/>
-        </p:spPr>
-        <p:txBody>
-          <a:bodyPr wrap="square" lIns="18288" rIns="18288" tIns="9144" bIns="9144">
+            <a:off x="530352" y="1115568"/>
+            <a:ext cx="10972800" cy="457200"/>
+          </a:xfrm>
+          <a:prstGeom prst="rect">
+            <a:avLst/>
+          </a:prstGeom>
+          <a:noFill/>
+        </p:spPr>
+        <p:txBody>
+          <a:bodyPr wrap="square" lIns="36576" rIns="36576" tIns="18288" bIns="18288">
             <a:spAutoFit/>
           </a:bodyPr>
           <a:lstStyle/>
           <a:p>
             <a:pPr>
-              <a:defRPr sz="1300" b="0">
+              <a:defRPr sz="1200" b="0">
                 <a:solidFill>
                   <a:srgbClr val="4B6268"/>
                 </a:solidFill>
@@ -4868,7 +5475,7 @@
               </a:defRPr>
             </a:pPr>
             <a:r>
-              <a:t>Lumen aims to make report wording easier to discuss; user benefit, adoption and clinical impact have not been measured.</a:t>
+              <a:t>The graphs count synthetic fixtures and automated checks; they are not model performance metrics.</a:t>
             </a:r>
           </a:p>
         </p:txBody>
@@ -4882,15 +5489,15 @@
         <p:spPr>
           <a:xfrm>
             <a:off x="502920" y="6510528"/>
-            <a:ext cx="9601200" cy="164592"/>
-          </a:xfrm>
-          <a:prstGeom prst="rect">
-            <a:avLst/>
-          </a:prstGeom>
-          <a:noFill/>
-        </p:spPr>
-        <p:txBody>
-          <a:bodyPr wrap="square" lIns="18288" rIns="18288" tIns="9144" bIns="9144">
+            <a:ext cx="9692640" cy="164592"/>
+          </a:xfrm>
+          <a:prstGeom prst="rect">
+            <a:avLst/>
+          </a:prstGeom>
+          <a:noFill/>
+        </p:spPr>
+        <p:txBody>
+          <a:bodyPr wrap="square" lIns="36576" rIns="36576" tIns="18288" bIns="18288">
             <a:spAutoFit/>
           </a:bodyPr>
           <a:lstStyle/>
@@ -4904,7 +5511,7 @@
               </a:defRPr>
             </a:pPr>
             <a:r>
-              <a:t>SYNTHETIC-ONLY  |  MODEL DISABLED  |  NOT FOR CLINICAL DECISIONS</a:t>
+              <a:t>SYNTHETIC-ONLY  |  MODEL OFF  |  NOT FOR CLINICAL DECISIONS</a:t>
             </a:r>
           </a:p>
         </p:txBody>
@@ -4926,7 +5533,7 @@
           <a:noFill/>
         </p:spPr>
         <p:txBody>
-          <a:bodyPr wrap="square" lIns="18288" rIns="18288" tIns="9144" bIns="9144">
+          <a:bodyPr wrap="square" lIns="36576" rIns="36576" tIns="18288" bIns="18288">
             <a:spAutoFit/>
           </a:bodyPr>
           <a:lstStyle/>
@@ -4945,16 +5552,40 @@
           </a:p>
         </p:txBody>
       </p:sp>
-      <p:sp>
-        <p:nvSpPr>
-          <p:cNvPr id="7" name="Rounded Rectangle 6"/>
+      <p:pic>
+        <p:nvPicPr>
+          <p:cNvPr id="7" name="Picture 6" descr="dataset_profile.png"/>
+          <p:cNvPicPr>
+            <a:picLocks noChangeAspect="1"/>
+          </p:cNvPicPr>
+          <p:nvPr/>
+        </p:nvPicPr>
+        <p:blipFill>
+          <a:blip r:embed="rId2"/>
+          <a:stretch>
+            <a:fillRect/>
+          </a:stretch>
+        </p:blipFill>
+        <p:spPr>
+          <a:xfrm>
+            <a:off x="621792" y="1700784"/>
+            <a:ext cx="10945368" cy="3273552"/>
+          </a:xfrm>
+          <a:prstGeom prst="rect">
+            <a:avLst/>
+          </a:prstGeom>
+        </p:spPr>
+      </p:pic>
+      <p:sp>
+        <p:nvSpPr>
+          <p:cNvPr id="8" name="Rounded Rectangle 7"/>
           <p:cNvSpPr/>
           <p:nvPr/>
         </p:nvSpPr>
         <p:spPr>
           <a:xfrm>
-            <a:off x="658368" y="1874519"/>
-            <a:ext cx="5285232" cy="2148840"/>
+            <a:off x="731520" y="5074920"/>
+            <a:ext cx="5303520" cy="1234440"/>
           </a:xfrm>
           <a:prstGeom prst="roundRect">
             <a:avLst/>
@@ -4992,28 +5623,28 @@
       </p:sp>
       <p:sp>
         <p:nvSpPr>
-          <p:cNvPr id="8" name="TextBox 7"/>
-          <p:cNvSpPr txBox="1"/>
-          <p:nvPr/>
-        </p:nvSpPr>
-        <p:spPr>
-          <a:xfrm>
-            <a:off x="896112" y="2103120"/>
-            <a:ext cx="4800600" cy="310896"/>
-          </a:xfrm>
-          <a:prstGeom prst="rect">
-            <a:avLst/>
-          </a:prstGeom>
-          <a:noFill/>
-        </p:spPr>
-        <p:txBody>
-          <a:bodyPr wrap="square" lIns="18288" rIns="18288" tIns="9144" bIns="9144">
+          <p:cNvPr id="9" name="TextBox 8"/>
+          <p:cNvSpPr txBox="1"/>
+          <p:nvPr/>
+        </p:nvSpPr>
+        <p:spPr>
+          <a:xfrm>
+            <a:off x="896112" y="5212080"/>
+            <a:ext cx="4937760" cy="182880"/>
+          </a:xfrm>
+          <a:prstGeom prst="rect">
+            <a:avLst/>
+          </a:prstGeom>
+          <a:noFill/>
+        </p:spPr>
+        <p:txBody>
+          <a:bodyPr wrap="square" lIns="36576" rIns="36576" tIns="18288" bIns="18288">
             <a:spAutoFit/>
           </a:bodyPr>
           <a:lstStyle/>
           <a:p>
             <a:pPr>
-              <a:defRPr sz="1200" b="1">
+              <a:defRPr sz="800" b="1">
                 <a:solidFill>
                   <a:srgbClr val="2E7D74"/>
                 </a:solidFill>
@@ -5021,68 +5652,30 @@
               </a:defRPr>
             </a:pPr>
             <a:r>
-              <a:t>POTENTIAL CONTRIBUTION</a:t>
-            </a:r>
-          </a:p>
-        </p:txBody>
-      </p:sp>
-      <p:sp>
-        <p:nvSpPr>
-          <p:cNvPr id="9" name="TextBox 8"/>
-          <p:cNvSpPr txBox="1"/>
-          <p:nvPr/>
-        </p:nvSpPr>
-        <p:spPr>
-          <a:xfrm>
-            <a:off x="896112" y="2578608"/>
-            <a:ext cx="4754880" cy="1143000"/>
-          </a:xfrm>
-          <a:prstGeom prst="rect">
-            <a:avLst/>
-          </a:prstGeom>
-          <a:noFill/>
-        </p:spPr>
-        <p:txBody>
-          <a:bodyPr wrap="square" lIns="18288" rIns="18288" tIns="9144" bIns="9144">
-            <a:spAutoFit/>
-          </a:bodyPr>
-          <a:lstStyle/>
-          <a:p>
-            <a:pPr>
-              <a:defRPr sz="1600" b="0">
-                <a:solidFill>
-                  <a:srgbClr val="18383E"/>
-                </a:solidFill>
-                <a:latin typeface="Aptos"/>
-              </a:defRPr>
-            </a:pPr>
-            <a:r>
-              <a:t>Keep exact report wording visible, preserve missing information as ‘not stated’, and offer neutral questions for a care-team conversation. This is a design hypothesis; no patient benefit has been demonstrated.</a:t>
-            </a:r>
-          </a:p>
-        </p:txBody>
-      </p:sp>
-      <p:sp>
-        <p:nvSpPr>
-          <p:cNvPr id="10" name="Rounded Rectangle 9"/>
+              <a:t>RED-TEAM INVENTORY  /  FIXTURE COUNTS, NOT PERFORMANCE</a:t>
+            </a:r>
+          </a:p>
+        </p:txBody>
+      </p:sp>
+      <p:sp>
+        <p:nvSpPr>
+          <p:cNvPr id="10" name="Rectangle 9"/>
           <p:cNvSpPr/>
           <p:nvPr/>
         </p:nvSpPr>
         <p:spPr>
           <a:xfrm>
-            <a:off x="6199632" y="1874519"/>
-            <a:ext cx="5285232" cy="2148840"/>
-          </a:xfrm>
-          <a:prstGeom prst="roundRect">
+            <a:off x="905256" y="5532120"/>
+            <a:ext cx="2468880" cy="265176"/>
+          </a:xfrm>
+          <a:prstGeom prst="rect">
             <a:avLst/>
           </a:prstGeom>
           <a:solidFill>
-            <a:srgbClr val="FFF5E3"/>
+            <a:srgbClr val="BE6B58"/>
           </a:solidFill>
-          <a:ln w="12700">
-            <a:solidFill>
-              <a:srgbClr val="EBD7AD"/>
-            </a:solidFill>
+          <a:ln>
+            <a:noFill/>
           </a:ln>
         </p:spPr>
         <p:style>
@@ -5115,127 +5708,53 @@
         </p:nvSpPr>
         <p:spPr>
           <a:xfrm>
-            <a:off x="6437376" y="2103120"/>
-            <a:ext cx="4754880" cy="310896"/>
-          </a:xfrm>
-          <a:prstGeom prst="rect">
-            <a:avLst/>
-          </a:prstGeom>
-          <a:noFill/>
-        </p:spPr>
-        <p:txBody>
-          <a:bodyPr wrap="square" lIns="18288" rIns="18288" tIns="9144" bIns="9144">
-            <a:spAutoFit/>
-          </a:bodyPr>
-          <a:lstStyle/>
-          <a:p>
-            <a:pPr>
-              <a:defRPr sz="1200" b="1">
-                <a:solidFill>
-                  <a:srgbClr val="9E6B1E"/>
-                </a:solidFill>
-                <a:latin typeface="Aptos"/>
-              </a:defRPr>
-            </a:pPr>
-            <a:r>
-              <a:t>FEASIBILITY TODAY</a:t>
-            </a:r>
-          </a:p>
-        </p:txBody>
-      </p:sp>
-      <p:sp>
-        <p:nvSpPr>
-          <p:cNvPr id="12" name="TextBox 11"/>
-          <p:cNvSpPr txBox="1"/>
-          <p:nvPr/>
-        </p:nvSpPr>
-        <p:spPr>
-          <a:xfrm>
-            <a:off x="6437376" y="2578608"/>
-            <a:ext cx="4736592" cy="1143000"/>
-          </a:xfrm>
-          <a:prstGeom prst="rect">
-            <a:avLst/>
-          </a:prstGeom>
-          <a:noFill/>
-        </p:spPr>
-        <p:txBody>
-          <a:bodyPr wrap="square" lIns="18288" rIns="18288" tIns="9144" bIns="9144">
-            <a:spAutoFit/>
-          </a:bodyPr>
-          <a:lstStyle/>
-          <a:p>
-            <a:pPr>
-              <a:defRPr sz="1500" b="0">
-                <a:solidFill>
-                  <a:srgbClr val="18383E"/>
-                </a:solidFill>
-                <a:latin typeface="Aptos"/>
-              </a:defRPr>
-            </a:pPr>
-            <a:r>
-              <a:t>A synthetic software prototype is tested locally. The provider is off; the positive result is a test fixture. Patient-facing use needs clinical review, human evaluation, privacy/operations and manual accessibility work.</a:t>
-            </a:r>
-          </a:p>
-        </p:txBody>
-      </p:sp>
-      <p:sp>
-        <p:nvSpPr>
-          <p:cNvPr id="13" name="TextBox 12"/>
-          <p:cNvSpPr txBox="1"/>
-          <p:nvPr/>
-        </p:nvSpPr>
-        <p:spPr>
-          <a:xfrm>
-            <a:off x="713232" y="4325112"/>
-            <a:ext cx="10789920" cy="274320"/>
-          </a:xfrm>
-          <a:prstGeom prst="rect">
-            <a:avLst/>
-          </a:prstGeom>
-          <a:noFill/>
-        </p:spPr>
-        <p:txBody>
-          <a:bodyPr wrap="square" lIns="18288" rIns="18288" tIns="9144" bIns="9144">
-            <a:spAutoFit/>
-          </a:bodyPr>
-          <a:lstStyle/>
-          <a:p>
-            <a:pPr>
-              <a:defRPr sz="1000" b="1">
-                <a:solidFill>
-                  <a:srgbClr val="2E7D74"/>
-                </a:solidFill>
-                <a:latin typeface="Aptos"/>
-              </a:defRPr>
-            </a:pPr>
-            <a:r>
-              <a:t>REQUIRED BEFORE ANY PATIENT-FACING CONSIDERATION</a:t>
-            </a:r>
-          </a:p>
-        </p:txBody>
-      </p:sp>
-      <p:sp>
-        <p:nvSpPr>
-          <p:cNvPr id="14" name="Rounded Rectangle 13"/>
+            <a:off x="923544" y="5582412"/>
+            <a:ext cx="2432304" cy="155448"/>
+          </a:xfrm>
+          <a:prstGeom prst="rect">
+            <a:avLst/>
+          </a:prstGeom>
+          <a:noFill/>
+        </p:spPr>
+        <p:txBody>
+          <a:bodyPr wrap="square" lIns="36576" rIns="36576" tIns="18288" bIns="18288">
+            <a:spAutoFit/>
+          </a:bodyPr>
+          <a:lstStyle/>
+          <a:p>
+            <a:pPr algn="ctr">
+              <a:defRPr sz="900" b="1">
+                <a:solidFill>
+                  <a:srgbClr val="FFFFFF"/>
+                </a:solidFill>
+                <a:latin typeface="Aptos"/>
+              </a:defRPr>
+            </a:pPr>
+            <a:r>
+              <a:t>8 critical</a:t>
+            </a:r>
+          </a:p>
+        </p:txBody>
+      </p:sp>
+      <p:sp>
+        <p:nvSpPr>
+          <p:cNvPr id="12" name="Rectangle 11"/>
           <p:cNvSpPr/>
           <p:nvPr/>
         </p:nvSpPr>
         <p:spPr>
           <a:xfrm>
-            <a:off x="658368" y="4736592"/>
-            <a:ext cx="2542032" cy="987552"/>
-          </a:xfrm>
-          <a:prstGeom prst="roundRect">
+            <a:off x="3374136" y="5532120"/>
+            <a:ext cx="923544" cy="265176"/>
+          </a:xfrm>
+          <a:prstGeom prst="rect">
             <a:avLst/>
           </a:prstGeom>
           <a:solidFill>
-            <a:srgbClr val="FFFFFF"/>
+            <a:srgbClr val="DDAA58"/>
           </a:solidFill>
-          <a:ln w="12700">
-            <a:solidFill>
-              <a:srgbClr val="D9E3DF"/>
-            </a:solidFill>
+          <a:ln>
+            <a:noFill/>
           </a:ln>
         </p:spPr>
         <p:style>
@@ -5262,64 +5781,28 @@
       </p:sp>
       <p:sp>
         <p:nvSpPr>
-          <p:cNvPr id="15" name="TextBox 14"/>
-          <p:cNvSpPr txBox="1"/>
-          <p:nvPr/>
-        </p:nvSpPr>
-        <p:spPr>
-          <a:xfrm>
-            <a:off x="813816" y="4919472"/>
-            <a:ext cx="347472" cy="210312"/>
-          </a:xfrm>
-          <a:prstGeom prst="rect">
-            <a:avLst/>
-          </a:prstGeom>
-          <a:noFill/>
-        </p:spPr>
-        <p:txBody>
-          <a:bodyPr wrap="square" lIns="18288" rIns="18288" tIns="9144" bIns="9144">
-            <a:spAutoFit/>
-          </a:bodyPr>
-          <a:lstStyle/>
-          <a:p>
-            <a:pPr>
-              <a:defRPr sz="1100" b="1">
-                <a:solidFill>
-                  <a:srgbClr val="2E7D74"/>
-                </a:solidFill>
-                <a:latin typeface="Aptos"/>
-              </a:defRPr>
-            </a:pPr>
-            <a:r>
-              <a:t>01</a:t>
-            </a:r>
-          </a:p>
-        </p:txBody>
-      </p:sp>
-      <p:sp>
-        <p:nvSpPr>
-          <p:cNvPr id="16" name="TextBox 15"/>
-          <p:cNvSpPr txBox="1"/>
-          <p:nvPr/>
-        </p:nvSpPr>
-        <p:spPr>
-          <a:xfrm>
-            <a:off x="1216152" y="4882896"/>
-            <a:ext cx="1847088" cy="457200"/>
-          </a:xfrm>
-          <a:prstGeom prst="rect">
-            <a:avLst/>
-          </a:prstGeom>
-          <a:noFill/>
-        </p:spPr>
-        <p:txBody>
-          <a:bodyPr wrap="square" lIns="18288" rIns="18288" tIns="9144" bIns="9144">
-            <a:spAutoFit/>
-          </a:bodyPr>
-          <a:lstStyle/>
-          <a:p>
-            <a:pPr>
-              <a:defRPr sz="1200" b="1">
+          <p:cNvPr id="13" name="TextBox 12"/>
+          <p:cNvSpPr txBox="1"/>
+          <p:nvPr/>
+        </p:nvSpPr>
+        <p:spPr>
+          <a:xfrm>
+            <a:off x="3392424" y="5582412"/>
+            <a:ext cx="886968" cy="155448"/>
+          </a:xfrm>
+          <a:prstGeom prst="rect">
+            <a:avLst/>
+          </a:prstGeom>
+          <a:noFill/>
+        </p:spPr>
+        <p:txBody>
+          <a:bodyPr wrap="square" lIns="36576" rIns="36576" tIns="18288" bIns="18288">
+            <a:spAutoFit/>
+          </a:bodyPr>
+          <a:lstStyle/>
+          <a:p>
+            <a:pPr algn="ctr">
+              <a:defRPr sz="900" b="1">
                 <a:solidFill>
                   <a:srgbClr val="18383E"/>
                 </a:solidFill>
@@ -5327,32 +5810,30 @@
               </a:defRPr>
             </a:pPr>
             <a:r>
-              <a:t>Clinical co-design</a:t>
-            </a:r>
-          </a:p>
-        </p:txBody>
-      </p:sp>
-      <p:sp>
-        <p:nvSpPr>
-          <p:cNvPr id="17" name="Rounded Rectangle 16"/>
+              <a:t>3 high</a:t>
+            </a:r>
+          </a:p>
+        </p:txBody>
+      </p:sp>
+      <p:sp>
+        <p:nvSpPr>
+          <p:cNvPr id="14" name="Rectangle 13"/>
           <p:cNvSpPr/>
           <p:nvPr/>
         </p:nvSpPr>
         <p:spPr>
           <a:xfrm>
-            <a:off x="3419856" y="4736592"/>
-            <a:ext cx="2542032" cy="987552"/>
-          </a:xfrm>
-          <a:prstGeom prst="roundRect">
+            <a:off x="4297680" y="5532120"/>
+            <a:ext cx="1545336" cy="265176"/>
+          </a:xfrm>
+          <a:prstGeom prst="rect">
             <a:avLst/>
           </a:prstGeom>
           <a:solidFill>
-            <a:srgbClr val="FFFFFF"/>
+            <a:srgbClr val="2E7D74"/>
           </a:solidFill>
-          <a:ln w="12700">
-            <a:solidFill>
-              <a:srgbClr val="D9E3DF"/>
-            </a:solidFill>
+          <a:ln>
+            <a:noFill/>
           </a:ln>
         </p:spPr>
         <p:style>
@@ -5379,86 +5860,86 @@
       </p:sp>
       <p:sp>
         <p:nvSpPr>
-          <p:cNvPr id="18" name="TextBox 17"/>
-          <p:cNvSpPr txBox="1"/>
-          <p:nvPr/>
-        </p:nvSpPr>
-        <p:spPr>
-          <a:xfrm>
-            <a:off x="3575304" y="4919472"/>
-            <a:ext cx="347472" cy="210312"/>
-          </a:xfrm>
-          <a:prstGeom prst="rect">
-            <a:avLst/>
-          </a:prstGeom>
-          <a:noFill/>
-        </p:spPr>
-        <p:txBody>
-          <a:bodyPr wrap="square" lIns="18288" rIns="18288" tIns="9144" bIns="9144">
+          <p:cNvPr id="15" name="TextBox 14"/>
+          <p:cNvSpPr txBox="1"/>
+          <p:nvPr/>
+        </p:nvSpPr>
+        <p:spPr>
+          <a:xfrm>
+            <a:off x="4315968" y="5582412"/>
+            <a:ext cx="1508760" cy="155448"/>
+          </a:xfrm>
+          <a:prstGeom prst="rect">
+            <a:avLst/>
+          </a:prstGeom>
+          <a:noFill/>
+        </p:spPr>
+        <p:txBody>
+          <a:bodyPr wrap="square" lIns="36576" rIns="36576" tIns="18288" bIns="18288">
+            <a:spAutoFit/>
+          </a:bodyPr>
+          <a:lstStyle/>
+          <a:p>
+            <a:pPr algn="ctr">
+              <a:defRPr sz="900" b="1">
+                <a:solidFill>
+                  <a:srgbClr val="FFFFFF"/>
+                </a:solidFill>
+                <a:latin typeface="Aptos"/>
+              </a:defRPr>
+            </a:pPr>
+            <a:r>
+              <a:t>5 controls</a:t>
+            </a:r>
+          </a:p>
+        </p:txBody>
+      </p:sp>
+      <p:sp>
+        <p:nvSpPr>
+          <p:cNvPr id="16" name="TextBox 15"/>
+          <p:cNvSpPr txBox="1"/>
+          <p:nvPr/>
+        </p:nvSpPr>
+        <p:spPr>
+          <a:xfrm>
+            <a:off x="896112" y="5943600"/>
+            <a:ext cx="4937760" cy="182880"/>
+          </a:xfrm>
+          <a:prstGeom prst="rect">
+            <a:avLst/>
+          </a:prstGeom>
+          <a:noFill/>
+        </p:spPr>
+        <p:txBody>
+          <a:bodyPr wrap="square" lIns="36576" rIns="36576" tIns="18288" bIns="18288">
             <a:spAutoFit/>
           </a:bodyPr>
           <a:lstStyle/>
           <a:p>
             <a:pPr>
-              <a:defRPr sz="1100" b="1">
-                <a:solidFill>
-                  <a:srgbClr val="2E7D74"/>
-                </a:solidFill>
-                <a:latin typeface="Aptos"/>
-              </a:defRPr>
-            </a:pPr>
-            <a:r>
-              <a:t>02</a:t>
-            </a:r>
-          </a:p>
-        </p:txBody>
-      </p:sp>
-      <p:sp>
-        <p:nvSpPr>
-          <p:cNvPr id="19" name="TextBox 18"/>
-          <p:cNvSpPr txBox="1"/>
-          <p:nvPr/>
-        </p:nvSpPr>
-        <p:spPr>
-          <a:xfrm>
-            <a:off x="3977640" y="4882896"/>
-            <a:ext cx="1847088" cy="457200"/>
-          </a:xfrm>
-          <a:prstGeom prst="rect">
-            <a:avLst/>
-          </a:prstGeom>
-          <a:noFill/>
-        </p:spPr>
-        <p:txBody>
-          <a:bodyPr wrap="square" lIns="18288" rIns="18288" tIns="9144" bIns="9144">
-            <a:spAutoFit/>
-          </a:bodyPr>
-          <a:lstStyle/>
-          <a:p>
-            <a:pPr>
-              <a:defRPr sz="1200" b="1">
-                <a:solidFill>
-                  <a:srgbClr val="18383E"/>
-                </a:solidFill>
-                <a:latin typeface="Aptos"/>
-              </a:defRPr>
-            </a:pPr>
-            <a:r>
-              <a:t>Human evaluation</a:t>
-            </a:r>
-          </a:p>
-        </p:txBody>
-      </p:sp>
-      <p:sp>
-        <p:nvSpPr>
-          <p:cNvPr id="20" name="Rounded Rectangle 19"/>
+              <a:defRPr sz="900" b="0">
+                <a:solidFill>
+                  <a:srgbClr val="4B6268"/>
+                </a:solidFill>
+                <a:latin typeface="Aptos"/>
+              </a:defRPr>
+            </a:pPr>
+            <a:r>
+              <a:t>16 cases catalogued; no model output evaluated.</a:t>
+            </a:r>
+          </a:p>
+        </p:txBody>
+      </p:sp>
+      <p:sp>
+        <p:nvSpPr>
+          <p:cNvPr id="17" name="Rounded Rectangle 16"/>
           <p:cNvSpPr/>
           <p:nvPr/>
         </p:nvSpPr>
         <p:spPr>
           <a:xfrm>
-            <a:off x="6181344" y="4736592"/>
-            <a:ext cx="2542032" cy="987552"/>
+            <a:off x="6199632" y="5074920"/>
+            <a:ext cx="5248656" cy="1234440"/>
           </a:xfrm>
           <a:prstGeom prst="roundRect">
             <a:avLst/>
@@ -5496,28 +5977,342 @@
       </p:sp>
       <p:sp>
         <p:nvSpPr>
+          <p:cNvPr id="18" name="TextBox 17"/>
+          <p:cNvSpPr txBox="1"/>
+          <p:nvPr/>
+        </p:nvSpPr>
+        <p:spPr>
+          <a:xfrm>
+            <a:off x="6400800" y="5212080"/>
+            <a:ext cx="4800600" cy="182880"/>
+          </a:xfrm>
+          <a:prstGeom prst="rect">
+            <a:avLst/>
+          </a:prstGeom>
+          <a:noFill/>
+        </p:spPr>
+        <p:txBody>
+          <a:bodyPr wrap="square" lIns="36576" rIns="36576" tIns="18288" bIns="18288">
+            <a:spAutoFit/>
+          </a:bodyPr>
+          <a:lstStyle/>
+          <a:p>
+            <a:pPr>
+              <a:defRPr sz="800" b="1">
+                <a:solidFill>
+                  <a:srgbClr val="2E7D74"/>
+                </a:solidFill>
+                <a:latin typeface="Aptos"/>
+              </a:defRPr>
+            </a:pPr>
+            <a:r>
+              <a:t>AUTOMATED SOFTWARE CHECKS</a:t>
+            </a:r>
+          </a:p>
+        </p:txBody>
+      </p:sp>
+      <p:sp>
+        <p:nvSpPr>
+          <p:cNvPr id="19" name="TextBox 18"/>
+          <p:cNvSpPr txBox="1"/>
+          <p:nvPr/>
+        </p:nvSpPr>
+        <p:spPr>
+          <a:xfrm>
+            <a:off x="6473952" y="5431536"/>
+            <a:ext cx="1325880" cy="365760"/>
+          </a:xfrm>
+          <a:prstGeom prst="rect">
+            <a:avLst/>
+          </a:prstGeom>
+          <a:noFill/>
+        </p:spPr>
+        <p:txBody>
+          <a:bodyPr wrap="square" lIns="36576" rIns="36576" tIns="18288" bIns="18288">
+            <a:spAutoFit/>
+          </a:bodyPr>
+          <a:lstStyle/>
+          <a:p>
+            <a:pPr algn="ctr">
+              <a:defRPr sz="2200" b="1">
+                <a:solidFill>
+                  <a:srgbClr val="18383E"/>
+                </a:solidFill>
+                <a:latin typeface="Aptos"/>
+              </a:defRPr>
+            </a:pPr>
+            <a:r>
+              <a:t>64</a:t>
+            </a:r>
+          </a:p>
+        </p:txBody>
+      </p:sp>
+      <p:sp>
+        <p:nvSpPr>
+          <p:cNvPr id="20" name="TextBox 19"/>
+          <p:cNvSpPr txBox="1"/>
+          <p:nvPr/>
+        </p:nvSpPr>
+        <p:spPr>
+          <a:xfrm>
+            <a:off x="6419088" y="5815584"/>
+            <a:ext cx="1435608" cy="201168"/>
+          </a:xfrm>
+          <a:prstGeom prst="rect">
+            <a:avLst/>
+          </a:prstGeom>
+          <a:noFill/>
+        </p:spPr>
+        <p:txBody>
+          <a:bodyPr wrap="square" lIns="36576" rIns="36576" tIns="18288" bIns="18288">
+            <a:spAutoFit/>
+          </a:bodyPr>
+          <a:lstStyle/>
+          <a:p>
+            <a:pPr algn="ctr">
+              <a:defRPr sz="900" b="0">
+                <a:solidFill>
+                  <a:srgbClr val="4B6268"/>
+                </a:solidFill>
+                <a:latin typeface="Aptos"/>
+              </a:defRPr>
+            </a:pPr>
+            <a:r>
+              <a:t>backend tests</a:t>
+            </a:r>
+          </a:p>
+        </p:txBody>
+      </p:sp>
+      <p:sp>
+        <p:nvSpPr>
           <p:cNvPr id="21" name="TextBox 20"/>
           <p:cNvSpPr txBox="1"/>
           <p:nvPr/>
         </p:nvSpPr>
         <p:spPr>
           <a:xfrm>
-            <a:off x="6336792" y="4919472"/>
-            <a:ext cx="347472" cy="210312"/>
-          </a:xfrm>
-          <a:prstGeom prst="rect">
-            <a:avLst/>
-          </a:prstGeom>
-          <a:noFill/>
-        </p:spPr>
-        <p:txBody>
-          <a:bodyPr wrap="square" lIns="18288" rIns="18288" tIns="9144" bIns="9144">
+            <a:off x="8119872" y="5431536"/>
+            <a:ext cx="1325880" cy="365760"/>
+          </a:xfrm>
+          <a:prstGeom prst="rect">
+            <a:avLst/>
+          </a:prstGeom>
+          <a:noFill/>
+        </p:spPr>
+        <p:txBody>
+          <a:bodyPr wrap="square" lIns="36576" rIns="36576" tIns="18288" bIns="18288">
+            <a:spAutoFit/>
+          </a:bodyPr>
+          <a:lstStyle/>
+          <a:p>
+            <a:pPr algn="ctr">
+              <a:defRPr sz="2200" b="1">
+                <a:solidFill>
+                  <a:srgbClr val="18383E"/>
+                </a:solidFill>
+                <a:latin typeface="Aptos"/>
+              </a:defRPr>
+            </a:pPr>
+            <a:r>
+              <a:t>10</a:t>
+            </a:r>
+          </a:p>
+        </p:txBody>
+      </p:sp>
+      <p:sp>
+        <p:nvSpPr>
+          <p:cNvPr id="22" name="TextBox 21"/>
+          <p:cNvSpPr txBox="1"/>
+          <p:nvPr/>
+        </p:nvSpPr>
+        <p:spPr>
+          <a:xfrm>
+            <a:off x="8065008" y="5815584"/>
+            <a:ext cx="1435608" cy="201168"/>
+          </a:xfrm>
+          <a:prstGeom prst="rect">
+            <a:avLst/>
+          </a:prstGeom>
+          <a:noFill/>
+        </p:spPr>
+        <p:txBody>
+          <a:bodyPr wrap="square" lIns="36576" rIns="36576" tIns="18288" bIns="18288">
+            <a:spAutoFit/>
+          </a:bodyPr>
+          <a:lstStyle/>
+          <a:p>
+            <a:pPr algn="ctr">
+              <a:defRPr sz="900" b="0">
+                <a:solidFill>
+                  <a:srgbClr val="4B6268"/>
+                </a:solidFill>
+                <a:latin typeface="Aptos"/>
+              </a:defRPr>
+            </a:pPr>
+            <a:r>
+              <a:t>browser tests</a:t>
+            </a:r>
+          </a:p>
+        </p:txBody>
+      </p:sp>
+      <p:sp>
+        <p:nvSpPr>
+          <p:cNvPr id="23" name="TextBox 22"/>
+          <p:cNvSpPr txBox="1"/>
+          <p:nvPr/>
+        </p:nvSpPr>
+        <p:spPr>
+          <a:xfrm>
+            <a:off x="9756648" y="5431536"/>
+            <a:ext cx="1325880" cy="365760"/>
+          </a:xfrm>
+          <a:prstGeom prst="rect">
+            <a:avLst/>
+          </a:prstGeom>
+          <a:noFill/>
+        </p:spPr>
+        <p:txBody>
+          <a:bodyPr wrap="square" lIns="36576" rIns="36576" tIns="18288" bIns="18288">
+            <a:spAutoFit/>
+          </a:bodyPr>
+          <a:lstStyle/>
+          <a:p>
+            <a:pPr algn="ctr">
+              <a:defRPr sz="2200" b="1">
+                <a:solidFill>
+                  <a:srgbClr val="18383E"/>
+                </a:solidFill>
+                <a:latin typeface="Aptos"/>
+              </a:defRPr>
+            </a:pPr>
+            <a:r>
+              <a:t>0</a:t>
+            </a:r>
+          </a:p>
+        </p:txBody>
+      </p:sp>
+      <p:sp>
+        <p:nvSpPr>
+          <p:cNvPr id="24" name="TextBox 23"/>
+          <p:cNvSpPr txBox="1"/>
+          <p:nvPr/>
+        </p:nvSpPr>
+        <p:spPr>
+          <a:xfrm>
+            <a:off x="9701784" y="5815584"/>
+            <a:ext cx="1435608" cy="201168"/>
+          </a:xfrm>
+          <a:prstGeom prst="rect">
+            <a:avLst/>
+          </a:prstGeom>
+          <a:noFill/>
+        </p:spPr>
+        <p:txBody>
+          <a:bodyPr wrap="square" lIns="36576" rIns="36576" tIns="18288" bIns="18288">
+            <a:spAutoFit/>
+          </a:bodyPr>
+          <a:lstStyle/>
+          <a:p>
+            <a:pPr algn="ctr">
+              <a:defRPr sz="900" b="0">
+                <a:solidFill>
+                  <a:srgbClr val="4B6268"/>
+                </a:solidFill>
+                <a:latin typeface="Aptos"/>
+              </a:defRPr>
+            </a:pPr>
+            <a:r>
+              <a:t>axe violations</a:t>
+            </a:r>
+          </a:p>
+        </p:txBody>
+      </p:sp>
+      <p:sp>
+        <p:nvSpPr>
+          <p:cNvPr id="25" name="TextBox 24"/>
+          <p:cNvSpPr txBox="1"/>
+          <p:nvPr/>
+        </p:nvSpPr>
+        <p:spPr>
+          <a:xfrm>
+            <a:off x="6400800" y="6062472"/>
+            <a:ext cx="4800600" cy="164592"/>
+          </a:xfrm>
+          <a:prstGeom prst="rect">
+            <a:avLst/>
+          </a:prstGeom>
+          <a:noFill/>
+        </p:spPr>
+        <p:txBody>
+          <a:bodyPr wrap="square" lIns="36576" rIns="36576" tIns="18288" bIns="18288">
             <a:spAutoFit/>
           </a:bodyPr>
           <a:lstStyle/>
           <a:p>
             <a:pPr>
-              <a:defRPr sz="1100" b="1">
+              <a:defRPr sz="800" b="0">
+                <a:solidFill>
+                  <a:srgbClr val="4B6268"/>
+                </a:solidFill>
+                <a:latin typeface="Aptos"/>
+              </a:defRPr>
+            </a:pPr>
+            <a:r>
+              <a:t>Tested states only; not a clinical or model-quality measure.</a:t>
+            </a:r>
+          </a:p>
+        </p:txBody>
+      </p:sp>
+    </p:spTree>
+  </p:cSld>
+  <p:clrMapOvr>
+    <a:masterClrMapping/>
+  </p:clrMapOvr>
+</p:sld>
+</file>
+
+<file path=ppt/slides/slide7.xml><?xml version="1.0" encoding="utf-8"?>
+<p:sld xmlns:a="http://schemas.openxmlformats.org/drawingml/2006/main" xmlns:p="http://schemas.openxmlformats.org/presentationml/2006/main" xmlns:r="http://schemas.openxmlformats.org/officeDocument/2006/relationships">
+  <p:cSld>
+    <p:bg>
+      <p:bgPr>
+        <a:solidFill>
+          <a:srgbClr val="F6F8F5"/>
+        </a:solidFill>
+        <a:effectLst/>
+      </p:bgPr>
+    </p:bg>
+    <p:spTree>
+      <p:nvGrpSpPr>
+        <p:cNvPr id="1" name=""/>
+        <p:cNvGrpSpPr/>
+        <p:nvPr/>
+      </p:nvGrpSpPr>
+      <p:grpSpPr/>
+      <p:sp>
+        <p:nvSpPr>
+          <p:cNvPr id="2" name="TextBox 1"/>
+          <p:cNvSpPr txBox="1"/>
+          <p:nvPr/>
+        </p:nvSpPr>
+        <p:spPr>
+          <a:xfrm>
+            <a:off x="530352" y="310896"/>
+            <a:ext cx="10972800" cy="201168"/>
+          </a:xfrm>
+          <a:prstGeom prst="rect">
+            <a:avLst/>
+          </a:prstGeom>
+          <a:noFill/>
+        </p:spPr>
+        <p:txBody>
+          <a:bodyPr wrap="square" lIns="36576" rIns="36576" tIns="18288" bIns="18288">
+            <a:spAutoFit/>
+          </a:bodyPr>
+          <a:lstStyle/>
+          <a:p>
+            <a:pPr>
+              <a:defRPr sz="900" b="1">
                 <a:solidFill>
                   <a:srgbClr val="2E7D74"/>
                 </a:solidFill>
@@ -5525,35 +6320,35 @@
               </a:defRPr>
             </a:pPr>
             <a:r>
-              <a:t>03</a:t>
-            </a:r>
-          </a:p>
-        </p:txBody>
-      </p:sp>
-      <p:sp>
-        <p:nvSpPr>
-          <p:cNvPr id="22" name="TextBox 21"/>
-          <p:cNvSpPr txBox="1"/>
-          <p:nvPr/>
-        </p:nvSpPr>
-        <p:spPr>
-          <a:xfrm>
-            <a:off x="6739128" y="4882896"/>
-            <a:ext cx="1847088" cy="457200"/>
-          </a:xfrm>
-          <a:prstGeom prst="rect">
-            <a:avLst/>
-          </a:prstGeom>
-          <a:noFill/>
-        </p:spPr>
-        <p:txBody>
-          <a:bodyPr wrap="square" lIns="18288" rIns="18288" tIns="9144" bIns="9144">
+              <a:t>06 / POTENTIAL IMPACT AND FEASIBILITY</a:t>
+            </a:r>
+          </a:p>
+        </p:txBody>
+      </p:sp>
+      <p:sp>
+        <p:nvSpPr>
+          <p:cNvPr id="3" name="TextBox 2"/>
+          <p:cNvSpPr txBox="1"/>
+          <p:nvPr/>
+        </p:nvSpPr>
+        <p:spPr>
+          <a:xfrm>
+            <a:off x="530352" y="621792"/>
+            <a:ext cx="11064240" cy="457200"/>
+          </a:xfrm>
+          <a:prstGeom prst="rect">
+            <a:avLst/>
+          </a:prstGeom>
+          <a:noFill/>
+        </p:spPr>
+        <p:txBody>
+          <a:bodyPr wrap="square" lIns="36576" rIns="36576" tIns="18288" bIns="18288">
             <a:spAutoFit/>
           </a:bodyPr>
           <a:lstStyle/>
           <a:p>
             <a:pPr>
-              <a:defRPr sz="1200" b="1">
+              <a:defRPr sz="2600" b="1">
                 <a:solidFill>
                   <a:srgbClr val="18383E"/>
                 </a:solidFill>
@@ -5561,21 +6356,129 @@
               </a:defRPr>
             </a:pPr>
             <a:r>
-              <a:t>Privacy + operations</a:t>
-            </a:r>
-          </a:p>
-        </p:txBody>
-      </p:sp>
-      <p:sp>
-        <p:nvSpPr>
-          <p:cNvPr id="23" name="Rounded Rectangle 22"/>
+              <a:t>A useful hypothesis - not a proven outcome</a:t>
+            </a:r>
+          </a:p>
+        </p:txBody>
+      </p:sp>
+      <p:sp>
+        <p:nvSpPr>
+          <p:cNvPr id="4" name="TextBox 3"/>
+          <p:cNvSpPr txBox="1"/>
+          <p:nvPr/>
+        </p:nvSpPr>
+        <p:spPr>
+          <a:xfrm>
+            <a:off x="530352" y="1115568"/>
+            <a:ext cx="10972800" cy="457200"/>
+          </a:xfrm>
+          <a:prstGeom prst="rect">
+            <a:avLst/>
+          </a:prstGeom>
+          <a:noFill/>
+        </p:spPr>
+        <p:txBody>
+          <a:bodyPr wrap="square" lIns="36576" rIns="36576" tIns="18288" bIns="18288">
+            <a:spAutoFit/>
+          </a:bodyPr>
+          <a:lstStyle/>
+          <a:p>
+            <a:pPr>
+              <a:defRPr sz="1200" b="0">
+                <a:solidFill>
+                  <a:srgbClr val="4B6268"/>
+                </a:solidFill>
+                <a:latin typeface="Aptos"/>
+              </a:defRPr>
+            </a:pPr>
+            <a:r>
+              <a:t>Source-linked wording may help someone prepare questions. User benefit, adoption, and clinical impact are unknown.</a:t>
+            </a:r>
+          </a:p>
+        </p:txBody>
+      </p:sp>
+      <p:sp>
+        <p:nvSpPr>
+          <p:cNvPr id="5" name="TextBox 4"/>
+          <p:cNvSpPr txBox="1"/>
+          <p:nvPr/>
+        </p:nvSpPr>
+        <p:spPr>
+          <a:xfrm>
+            <a:off x="502920" y="6510528"/>
+            <a:ext cx="9692640" cy="164592"/>
+          </a:xfrm>
+          <a:prstGeom prst="rect">
+            <a:avLst/>
+          </a:prstGeom>
+          <a:noFill/>
+        </p:spPr>
+        <p:txBody>
+          <a:bodyPr wrap="square" lIns="36576" rIns="36576" tIns="18288" bIns="18288">
+            <a:spAutoFit/>
+          </a:bodyPr>
+          <a:lstStyle/>
+          <a:p>
+            <a:pPr>
+              <a:defRPr sz="800" b="1">
+                <a:solidFill>
+                  <a:srgbClr val="71848A"/>
+                </a:solidFill>
+                <a:latin typeface="Aptos"/>
+              </a:defRPr>
+            </a:pPr>
+            <a:r>
+              <a:t>SYNTHETIC-ONLY  |  MODEL OFF  |  NOT FOR CLINICAL DECISIONS</a:t>
+            </a:r>
+          </a:p>
+        </p:txBody>
+      </p:sp>
+      <p:sp>
+        <p:nvSpPr>
+          <p:cNvPr id="6" name="TextBox 5"/>
+          <p:cNvSpPr txBox="1"/>
+          <p:nvPr/>
+        </p:nvSpPr>
+        <p:spPr>
+          <a:xfrm>
+            <a:off x="11155680" y="6492240"/>
+            <a:ext cx="457200" cy="182880"/>
+          </a:xfrm>
+          <a:prstGeom prst="rect">
+            <a:avLst/>
+          </a:prstGeom>
+          <a:noFill/>
+        </p:spPr>
+        <p:txBody>
+          <a:bodyPr wrap="square" lIns="36576" rIns="36576" tIns="18288" bIns="18288">
+            <a:spAutoFit/>
+          </a:bodyPr>
+          <a:lstStyle/>
+          <a:p>
+            <a:pPr algn="r">
+              <a:defRPr sz="900" b="1">
+                <a:solidFill>
+                  <a:srgbClr val="2E7D74"/>
+                </a:solidFill>
+                <a:latin typeface="Aptos"/>
+              </a:defRPr>
+            </a:pPr>
+            <a:r>
+              <a:t>07</a:t>
+            </a:r>
+          </a:p>
+        </p:txBody>
+      </p:sp>
+      <p:sp>
+        <p:nvSpPr>
+          <p:cNvPr id="7" name="Rounded Rectangle 6"/>
           <p:cNvSpPr/>
           <p:nvPr/>
         </p:nvSpPr>
         <p:spPr>
           <a:xfrm>
-            <a:off x="8942832" y="4736592"/>
-            <a:ext cx="2542032" cy="987552"/>
+            <a:off x="676656" y="1828800"/>
+            <a:ext cx="5285232" cy="1965960"/>
           </a:xfrm>
           <a:prstGeom prst="roundRect">
             <a:avLst/>
@@ -5613,58 +6516,22 @@
       </p:sp>
       <p:sp>
         <p:nvSpPr>
-          <p:cNvPr id="24" name="TextBox 23"/>
-          <p:cNvSpPr txBox="1"/>
-          <p:nvPr/>
-        </p:nvSpPr>
-        <p:spPr>
-          <a:xfrm>
-            <a:off x="9098280" y="4919472"/>
-            <a:ext cx="347472" cy="210312"/>
-          </a:xfrm>
-          <a:prstGeom prst="rect">
-            <a:avLst/>
-          </a:prstGeom>
-          <a:noFill/>
-        </p:spPr>
-        <p:txBody>
-          <a:bodyPr wrap="square" lIns="18288" rIns="18288" tIns="9144" bIns="9144">
-            <a:spAutoFit/>
-          </a:bodyPr>
-          <a:lstStyle/>
-          <a:p>
-            <a:pPr>
-              <a:defRPr sz="1100" b="1">
-                <a:solidFill>
-                  <a:srgbClr val="2E7D74"/>
-                </a:solidFill>
-                <a:latin typeface="Aptos"/>
-              </a:defRPr>
-            </a:pPr>
-            <a:r>
-              <a:t>04</a:t>
-            </a:r>
-          </a:p>
-        </p:txBody>
-      </p:sp>
-      <p:sp>
-        <p:nvSpPr>
-          <p:cNvPr id="25" name="TextBox 24"/>
-          <p:cNvSpPr txBox="1"/>
-          <p:nvPr/>
-        </p:nvSpPr>
-        <p:spPr>
-          <a:xfrm>
-            <a:off x="9500616" y="4882896"/>
-            <a:ext cx="1847088" cy="457200"/>
-          </a:xfrm>
-          <a:prstGeom prst="rect">
-            <a:avLst/>
-          </a:prstGeom>
-          <a:noFill/>
-        </p:spPr>
-        <p:txBody>
-          <a:bodyPr wrap="square" lIns="18288" rIns="18288" tIns="9144" bIns="9144">
+          <p:cNvPr id="8" name="TextBox 7"/>
+          <p:cNvSpPr txBox="1"/>
+          <p:nvPr/>
+        </p:nvSpPr>
+        <p:spPr>
+          <a:xfrm>
+            <a:off x="896112" y="2057400"/>
+            <a:ext cx="4800600" cy="256032"/>
+          </a:xfrm>
+          <a:prstGeom prst="rect">
+            <a:avLst/>
+          </a:prstGeom>
+          <a:noFill/>
+        </p:spPr>
+        <p:txBody>
+          <a:bodyPr wrap="square" lIns="36576" rIns="36576" tIns="18288" bIns="18288">
             <a:spAutoFit/>
           </a:bodyPr>
           <a:lstStyle/>
@@ -5672,37 +6539,73 @@
             <a:pPr>
               <a:defRPr sz="1200" b="1">
                 <a:solidFill>
+                  <a:srgbClr val="2E7D74"/>
+                </a:solidFill>
+                <a:latin typeface="Aptos"/>
+              </a:defRPr>
+            </a:pPr>
+            <a:r>
+              <a:t>POTENTIAL CONTRIBUTION</a:t>
+            </a:r>
+          </a:p>
+        </p:txBody>
+      </p:sp>
+      <p:sp>
+        <p:nvSpPr>
+          <p:cNvPr id="9" name="TextBox 8"/>
+          <p:cNvSpPr txBox="1"/>
+          <p:nvPr/>
+        </p:nvSpPr>
+        <p:spPr>
+          <a:xfrm>
+            <a:off x="896112" y="2487168"/>
+            <a:ext cx="4773168" cy="960120"/>
+          </a:xfrm>
+          <a:prstGeom prst="rect">
+            <a:avLst/>
+          </a:prstGeom>
+          <a:noFill/>
+        </p:spPr>
+        <p:txBody>
+          <a:bodyPr wrap="square" lIns="36576" rIns="36576" tIns="18288" bIns="18288">
+            <a:spAutoFit/>
+          </a:bodyPr>
+          <a:lstStyle/>
+          <a:p>
+            <a:pPr>
+              <a:defRPr sz="1600" b="0">
+                <a:solidFill>
                   <a:srgbClr val="18383E"/>
                 </a:solidFill>
                 <a:latin typeface="Aptos"/>
               </a:defRPr>
             </a:pPr>
             <a:r>
-              <a:t>Accessibility review</a:t>
-            </a:r>
-          </a:p>
-        </p:txBody>
-      </p:sp>
-      <p:sp>
-        <p:nvSpPr>
-          <p:cNvPr id="26" name="Rounded Rectangle 25"/>
+              <a:t>Keep source wording visible, mark absent facts as ‘not stated’, and offer neutral care-team questions. This intention has not been evaluated with patients.</a:t>
+            </a:r>
+          </a:p>
+        </p:txBody>
+      </p:sp>
+      <p:sp>
+        <p:nvSpPr>
+          <p:cNvPr id="10" name="Rounded Rectangle 9"/>
           <p:cNvSpPr/>
           <p:nvPr/>
         </p:nvSpPr>
         <p:spPr>
           <a:xfrm>
-            <a:off x="658368" y="5897880"/>
-            <a:ext cx="10826496" cy="384048"/>
+            <a:off x="6199632" y="1828800"/>
+            <a:ext cx="5285232" cy="1965960"/>
           </a:xfrm>
           <a:prstGeom prst="roundRect">
             <a:avLst/>
           </a:prstGeom>
           <a:solidFill>
-            <a:srgbClr val="18383E"/>
+            <a:srgbClr val="FFF5E3"/>
           </a:solidFill>
           <a:ln w="12700">
             <a:solidFill>
-              <a:srgbClr val="18383E"/>
+              <a:srgbClr val="EBD7AD"/>
             </a:solidFill>
           </a:ln>
         </p:spPr>
@@ -5730,22 +6633,94 @@
       </p:sp>
       <p:sp>
         <p:nvSpPr>
-          <p:cNvPr id="27" name="TextBox 26"/>
-          <p:cNvSpPr txBox="1"/>
-          <p:nvPr/>
-        </p:nvSpPr>
-        <p:spPr>
-          <a:xfrm>
-            <a:off x="859536" y="5989320"/>
-            <a:ext cx="10424160" cy="164592"/>
-          </a:xfrm>
-          <a:prstGeom prst="rect">
-            <a:avLst/>
-          </a:prstGeom>
-          <a:noFill/>
-        </p:spPr>
-        <p:txBody>
-          <a:bodyPr wrap="square" lIns="18288" rIns="18288" tIns="9144" bIns="9144">
+          <p:cNvPr id="11" name="TextBox 10"/>
+          <p:cNvSpPr txBox="1"/>
+          <p:nvPr/>
+        </p:nvSpPr>
+        <p:spPr>
+          <a:xfrm>
+            <a:off x="6419088" y="2057400"/>
+            <a:ext cx="4773168" cy="256032"/>
+          </a:xfrm>
+          <a:prstGeom prst="rect">
+            <a:avLst/>
+          </a:prstGeom>
+          <a:noFill/>
+        </p:spPr>
+        <p:txBody>
+          <a:bodyPr wrap="square" lIns="36576" rIns="36576" tIns="18288" bIns="18288">
+            <a:spAutoFit/>
+          </a:bodyPr>
+          <a:lstStyle/>
+          <a:p>
+            <a:pPr>
+              <a:defRPr sz="1200" b="1">
+                <a:solidFill>
+                  <a:srgbClr val="9E6B1E"/>
+                </a:solidFill>
+                <a:latin typeface="Aptos"/>
+              </a:defRPr>
+            </a:pPr>
+            <a:r>
+              <a:t>FEASIBILITY CONDITIONS</a:t>
+            </a:r>
+          </a:p>
+        </p:txBody>
+      </p:sp>
+      <p:sp>
+        <p:nvSpPr>
+          <p:cNvPr id="12" name="TextBox 11"/>
+          <p:cNvSpPr txBox="1"/>
+          <p:nvPr/>
+        </p:nvSpPr>
+        <p:spPr>
+          <a:xfrm>
+            <a:off x="6419088" y="2487168"/>
+            <a:ext cx="4736592" cy="960120"/>
+          </a:xfrm>
+          <a:prstGeom prst="rect">
+            <a:avLst/>
+          </a:prstGeom>
+          <a:noFill/>
+        </p:spPr>
+        <p:txBody>
+          <a:bodyPr wrap="square" lIns="36576" rIns="36576" tIns="18288" bIns="18288">
+            <a:spAutoFit/>
+          </a:bodyPr>
+          <a:lstStyle/>
+          <a:p>
+            <a:pPr>
+              <a:defRPr sz="1500" b="0">
+                <a:solidFill>
+                  <a:srgbClr val="18383E"/>
+                </a:solidFill>
+                <a:latin typeface="Aptos"/>
+              </a:defRPr>
+            </a:pPr>
+            <a:r>
+              <a:t>Clinical co-design • human-labeled output review • provider/privacy assessment • manual accessibility checks • deployment and abuse controls.</a:t>
+            </a:r>
+          </a:p>
+        </p:txBody>
+      </p:sp>
+      <p:sp>
+        <p:nvSpPr>
+          <p:cNvPr id="13" name="TextBox 12"/>
+          <p:cNvSpPr txBox="1"/>
+          <p:nvPr/>
+        </p:nvSpPr>
+        <p:spPr>
+          <a:xfrm>
+            <a:off x="749808" y="4160520"/>
+            <a:ext cx="10789920" cy="274320"/>
+          </a:xfrm>
+          <a:prstGeom prst="rect">
+            <a:avLst/>
+          </a:prstGeom>
+          <a:noFill/>
+        </p:spPr>
+        <p:txBody>
+          <a:bodyPr wrap="square" lIns="36576" rIns="36576" tIns="18288" bIns="18288">
             <a:spAutoFit/>
           </a:bodyPr>
           <a:lstStyle/>
@@ -5753,13 +6728,418 @@
             <a:pPr>
               <a:defRPr sz="1000" b="1">
                 <a:solidFill>
+                  <a:srgbClr val="2E7D74"/>
+                </a:solidFill>
+                <a:latin typeface="Aptos"/>
+              </a:defRPr>
+            </a:pPr>
+            <a:r>
+              <a:t>PATH BEFORE ANY PATIENT-FACING CONSIDERATION</a:t>
+            </a:r>
+          </a:p>
+        </p:txBody>
+      </p:sp>
+      <p:sp>
+        <p:nvSpPr>
+          <p:cNvPr id="14" name="Rounded Rectangle 13"/>
+          <p:cNvSpPr/>
+          <p:nvPr/>
+        </p:nvSpPr>
+        <p:spPr>
+          <a:xfrm>
+            <a:off x="694944" y="4599432"/>
+            <a:ext cx="2542032" cy="749808"/>
+          </a:xfrm>
+          <a:prstGeom prst="roundRect">
+            <a:avLst/>
+          </a:prstGeom>
+          <a:solidFill>
+            <a:srgbClr val="FFFFFF"/>
+          </a:solidFill>
+          <a:ln w="12700">
+            <a:solidFill>
+              <a:srgbClr val="D9E3DF"/>
+            </a:solidFill>
+          </a:ln>
+        </p:spPr>
+        <p:style>
+          <a:lnRef idx="1">
+            <a:schemeClr val="accent1"/>
+          </a:lnRef>
+          <a:fillRef idx="3">
+            <a:schemeClr val="accent1"/>
+          </a:fillRef>
+          <a:effectRef idx="2">
+            <a:schemeClr val="accent1"/>
+          </a:effectRef>
+          <a:fontRef idx="minor">
+            <a:schemeClr val="lt1"/>
+          </a:fontRef>
+        </p:style>
+        <p:txBody>
+          <a:bodyPr rtlCol="0" anchor="ctr"/>
+          <a:lstStyle/>
+          <a:p>
+            <a:pPr algn="ctr"/>
+          </a:p>
+        </p:txBody>
+      </p:sp>
+      <p:sp>
+        <p:nvSpPr>
+          <p:cNvPr id="15" name="TextBox 14"/>
+          <p:cNvSpPr txBox="1"/>
+          <p:nvPr/>
+        </p:nvSpPr>
+        <p:spPr>
+          <a:xfrm>
+            <a:off x="841248" y="4818888"/>
+            <a:ext cx="2240280" cy="256032"/>
+          </a:xfrm>
+          <a:prstGeom prst="rect">
+            <a:avLst/>
+          </a:prstGeom>
+          <a:noFill/>
+        </p:spPr>
+        <p:txBody>
+          <a:bodyPr wrap="square" lIns="36576" rIns="36576" tIns="18288" bIns="18288">
+            <a:spAutoFit/>
+          </a:bodyPr>
+          <a:lstStyle/>
+          <a:p>
+            <a:pPr>
+              <a:defRPr sz="1200" b="1">
+                <a:solidFill>
+                  <a:srgbClr val="18383E"/>
+                </a:solidFill>
+                <a:latin typeface="Aptos"/>
+              </a:defRPr>
+            </a:pPr>
+            <a:r>
+              <a:t>1  Clinical review</a:t>
+            </a:r>
+          </a:p>
+        </p:txBody>
+      </p:sp>
+      <p:sp>
+        <p:nvSpPr>
+          <p:cNvPr id="16" name="Rounded Rectangle 15"/>
+          <p:cNvSpPr/>
+          <p:nvPr/>
+        </p:nvSpPr>
+        <p:spPr>
+          <a:xfrm>
+            <a:off x="3456432" y="4599432"/>
+            <a:ext cx="2542032" cy="749808"/>
+          </a:xfrm>
+          <a:prstGeom prst="roundRect">
+            <a:avLst/>
+          </a:prstGeom>
+          <a:solidFill>
+            <a:srgbClr val="FFFFFF"/>
+          </a:solidFill>
+          <a:ln w="12700">
+            <a:solidFill>
+              <a:srgbClr val="D9E3DF"/>
+            </a:solidFill>
+          </a:ln>
+        </p:spPr>
+        <p:style>
+          <a:lnRef idx="1">
+            <a:schemeClr val="accent1"/>
+          </a:lnRef>
+          <a:fillRef idx="3">
+            <a:schemeClr val="accent1"/>
+          </a:fillRef>
+          <a:effectRef idx="2">
+            <a:schemeClr val="accent1"/>
+          </a:effectRef>
+          <a:fontRef idx="minor">
+            <a:schemeClr val="lt1"/>
+          </a:fontRef>
+        </p:style>
+        <p:txBody>
+          <a:bodyPr rtlCol="0" anchor="ctr"/>
+          <a:lstStyle/>
+          <a:p>
+            <a:pPr algn="ctr"/>
+          </a:p>
+        </p:txBody>
+      </p:sp>
+      <p:sp>
+        <p:nvSpPr>
+          <p:cNvPr id="17" name="TextBox 16"/>
+          <p:cNvSpPr txBox="1"/>
+          <p:nvPr/>
+        </p:nvSpPr>
+        <p:spPr>
+          <a:xfrm>
+            <a:off x="3602736" y="4818888"/>
+            <a:ext cx="2240280" cy="256032"/>
+          </a:xfrm>
+          <a:prstGeom prst="rect">
+            <a:avLst/>
+          </a:prstGeom>
+          <a:noFill/>
+        </p:spPr>
+        <p:txBody>
+          <a:bodyPr wrap="square" lIns="36576" rIns="36576" tIns="18288" bIns="18288">
+            <a:spAutoFit/>
+          </a:bodyPr>
+          <a:lstStyle/>
+          <a:p>
+            <a:pPr>
+              <a:defRPr sz="1200" b="1">
+                <a:solidFill>
+                  <a:srgbClr val="18383E"/>
+                </a:solidFill>
+                <a:latin typeface="Aptos"/>
+              </a:defRPr>
+            </a:pPr>
+            <a:r>
+              <a:t>2  Human evaluation</a:t>
+            </a:r>
+          </a:p>
+        </p:txBody>
+      </p:sp>
+      <p:sp>
+        <p:nvSpPr>
+          <p:cNvPr id="18" name="Rounded Rectangle 17"/>
+          <p:cNvSpPr/>
+          <p:nvPr/>
+        </p:nvSpPr>
+        <p:spPr>
+          <a:xfrm>
+            <a:off x="6217920" y="4599432"/>
+            <a:ext cx="2542032" cy="749808"/>
+          </a:xfrm>
+          <a:prstGeom prst="roundRect">
+            <a:avLst/>
+          </a:prstGeom>
+          <a:solidFill>
+            <a:srgbClr val="FFFFFF"/>
+          </a:solidFill>
+          <a:ln w="12700">
+            <a:solidFill>
+              <a:srgbClr val="D9E3DF"/>
+            </a:solidFill>
+          </a:ln>
+        </p:spPr>
+        <p:style>
+          <a:lnRef idx="1">
+            <a:schemeClr val="accent1"/>
+          </a:lnRef>
+          <a:fillRef idx="3">
+            <a:schemeClr val="accent1"/>
+          </a:fillRef>
+          <a:effectRef idx="2">
+            <a:schemeClr val="accent1"/>
+          </a:effectRef>
+          <a:fontRef idx="minor">
+            <a:schemeClr val="lt1"/>
+          </a:fontRef>
+        </p:style>
+        <p:txBody>
+          <a:bodyPr rtlCol="0" anchor="ctr"/>
+          <a:lstStyle/>
+          <a:p>
+            <a:pPr algn="ctr"/>
+          </a:p>
+        </p:txBody>
+      </p:sp>
+      <p:sp>
+        <p:nvSpPr>
+          <p:cNvPr id="19" name="TextBox 18"/>
+          <p:cNvSpPr txBox="1"/>
+          <p:nvPr/>
+        </p:nvSpPr>
+        <p:spPr>
+          <a:xfrm>
+            <a:off x="6364224" y="4818888"/>
+            <a:ext cx="2240280" cy="256032"/>
+          </a:xfrm>
+          <a:prstGeom prst="rect">
+            <a:avLst/>
+          </a:prstGeom>
+          <a:noFill/>
+        </p:spPr>
+        <p:txBody>
+          <a:bodyPr wrap="square" lIns="36576" rIns="36576" tIns="18288" bIns="18288">
+            <a:spAutoFit/>
+          </a:bodyPr>
+          <a:lstStyle/>
+          <a:p>
+            <a:pPr>
+              <a:defRPr sz="1200" b="1">
+                <a:solidFill>
+                  <a:srgbClr val="18383E"/>
+                </a:solidFill>
+                <a:latin typeface="Aptos"/>
+              </a:defRPr>
+            </a:pPr>
+            <a:r>
+              <a:t>3  Privacy + ops</a:t>
+            </a:r>
+          </a:p>
+        </p:txBody>
+      </p:sp>
+      <p:sp>
+        <p:nvSpPr>
+          <p:cNvPr id="20" name="Rounded Rectangle 19"/>
+          <p:cNvSpPr/>
+          <p:nvPr/>
+        </p:nvSpPr>
+        <p:spPr>
+          <a:xfrm>
+            <a:off x="8979408" y="4599432"/>
+            <a:ext cx="2542032" cy="749808"/>
+          </a:xfrm>
+          <a:prstGeom prst="roundRect">
+            <a:avLst/>
+          </a:prstGeom>
+          <a:solidFill>
+            <a:srgbClr val="FFFFFF"/>
+          </a:solidFill>
+          <a:ln w="12700">
+            <a:solidFill>
+              <a:srgbClr val="D9E3DF"/>
+            </a:solidFill>
+          </a:ln>
+        </p:spPr>
+        <p:style>
+          <a:lnRef idx="1">
+            <a:schemeClr val="accent1"/>
+          </a:lnRef>
+          <a:fillRef idx="3">
+            <a:schemeClr val="accent1"/>
+          </a:fillRef>
+          <a:effectRef idx="2">
+            <a:schemeClr val="accent1"/>
+          </a:effectRef>
+          <a:fontRef idx="minor">
+            <a:schemeClr val="lt1"/>
+          </a:fontRef>
+        </p:style>
+        <p:txBody>
+          <a:bodyPr rtlCol="0" anchor="ctr"/>
+          <a:lstStyle/>
+          <a:p>
+            <a:pPr algn="ctr"/>
+          </a:p>
+        </p:txBody>
+      </p:sp>
+      <p:sp>
+        <p:nvSpPr>
+          <p:cNvPr id="21" name="TextBox 20"/>
+          <p:cNvSpPr txBox="1"/>
+          <p:nvPr/>
+        </p:nvSpPr>
+        <p:spPr>
+          <a:xfrm>
+            <a:off x="9125712" y="4818888"/>
+            <a:ext cx="2240280" cy="256032"/>
+          </a:xfrm>
+          <a:prstGeom prst="rect">
+            <a:avLst/>
+          </a:prstGeom>
+          <a:noFill/>
+        </p:spPr>
+        <p:txBody>
+          <a:bodyPr wrap="square" lIns="36576" rIns="36576" tIns="18288" bIns="18288">
+            <a:spAutoFit/>
+          </a:bodyPr>
+          <a:lstStyle/>
+          <a:p>
+            <a:pPr>
+              <a:defRPr sz="1200" b="1">
+                <a:solidFill>
+                  <a:srgbClr val="18383E"/>
+                </a:solidFill>
+                <a:latin typeface="Aptos"/>
+              </a:defRPr>
+            </a:pPr>
+            <a:r>
+              <a:t>4  Accessibility</a:t>
+            </a:r>
+          </a:p>
+        </p:txBody>
+      </p:sp>
+      <p:sp>
+        <p:nvSpPr>
+          <p:cNvPr id="22" name="Rounded Rectangle 21"/>
+          <p:cNvSpPr/>
+          <p:nvPr/>
+        </p:nvSpPr>
+        <p:spPr>
+          <a:xfrm>
+            <a:off x="694944" y="5623560"/>
+            <a:ext cx="10808208" cy="530352"/>
+          </a:xfrm>
+          <a:prstGeom prst="roundRect">
+            <a:avLst/>
+          </a:prstGeom>
+          <a:solidFill>
+            <a:srgbClr val="18383E"/>
+          </a:solidFill>
+          <a:ln w="12700">
+            <a:solidFill>
+              <a:srgbClr val="18383E"/>
+            </a:solidFill>
+          </a:ln>
+        </p:spPr>
+        <p:style>
+          <a:lnRef idx="1">
+            <a:schemeClr val="accent1"/>
+          </a:lnRef>
+          <a:fillRef idx="3">
+            <a:schemeClr val="accent1"/>
+          </a:fillRef>
+          <a:effectRef idx="2">
+            <a:schemeClr val="accent1"/>
+          </a:effectRef>
+          <a:fontRef idx="minor">
+            <a:schemeClr val="lt1"/>
+          </a:fontRef>
+        </p:style>
+        <p:txBody>
+          <a:bodyPr rtlCol="0" anchor="ctr"/>
+          <a:lstStyle/>
+          <a:p>
+            <a:pPr algn="ctr"/>
+          </a:p>
+        </p:txBody>
+      </p:sp>
+      <p:sp>
+        <p:nvSpPr>
+          <p:cNvPr id="23" name="TextBox 22"/>
+          <p:cNvSpPr txBox="1"/>
+          <p:nvPr/>
+        </p:nvSpPr>
+        <p:spPr>
+          <a:xfrm>
+            <a:off x="896112" y="5760720"/>
+            <a:ext cx="10378440" cy="228600"/>
+          </a:xfrm>
+          <a:prstGeom prst="rect">
+            <a:avLst/>
+          </a:prstGeom>
+          <a:noFill/>
+        </p:spPr>
+        <p:txBody>
+          <a:bodyPr wrap="square" lIns="36576" rIns="36576" tIns="18288" bIns="18288">
+            <a:spAutoFit/>
+          </a:bodyPr>
+          <a:lstStyle/>
+          <a:p>
+            <a:pPr>
+              <a:defRPr sz="1200" b="1">
+                <a:solidFill>
                   <a:srgbClr val="FFFFFF"/>
                 </a:solidFill>
                 <a:latin typeface="Aptos"/>
               </a:defRPr>
             </a:pPr>
             <a:r>
-              <a:t>No clinical validation or patient benefit is claimed. Current status: Gate 2 not passed; model disabled.</a:t>
+              <a:t>Gate 2 not passed. No patient benefit is claimed; no real patient data used.</a:t>
             </a:r>
           </a:p>
         </p:txBody>
@@ -5772,7 +7152,7 @@
 </p:sld>
 </file>
 
-<file path=ppt/slides/slide7.xml><?xml version="1.0" encoding="utf-8"?>
+<file path=ppt/slides/slide8.xml><?xml version="1.0" encoding="utf-8"?>
 <p:sld xmlns:a="http://schemas.openxmlformats.org/drawingml/2006/main" xmlns:p="http://schemas.openxmlformats.org/presentationml/2006/main" xmlns:r="http://schemas.openxmlformats.org/officeDocument/2006/relationships">
   <p:cSld>
     <p:bg>
@@ -5807,7 +7187,7 @@
           <a:noFill/>
         </p:spPr>
         <p:txBody>
-          <a:bodyPr wrap="square" lIns="18288" rIns="18288" tIns="9144" bIns="9144">
+          <a:bodyPr wrap="square" lIns="36576" rIns="36576" tIns="18288" bIns="18288">
             <a:spAutoFit/>
           </a:bodyPr>
           <a:lstStyle/>
@@ -5834,7 +7214,7 @@
         </p:nvSpPr>
         <p:spPr>
           <a:xfrm>
-            <a:off x="658368" y="1234440"/>
+            <a:off x="658368" y="1170432"/>
             <a:ext cx="10789920" cy="685800"/>
           </a:xfrm>
           <a:prstGeom prst="rect">
@@ -5843,7 +7223,7 @@
           <a:noFill/>
         </p:spPr>
         <p:txBody>
-          <a:bodyPr wrap="square" lIns="18288" rIns="18288" tIns="9144" bIns="9144">
+          <a:bodyPr wrap="square" lIns="36576" rIns="36576" tIns="18288" bIns="18288">
             <a:spAutoFit/>
           </a:bodyPr>
           <a:lstStyle/>
@@ -5870,22 +7250,22 @@
         </p:nvSpPr>
         <p:spPr>
           <a:xfrm>
-            <a:off x="694944" y="2148840"/>
-            <a:ext cx="9875520" cy="502920"/>
-          </a:xfrm>
-          <a:prstGeom prst="rect">
-            <a:avLst/>
-          </a:prstGeom>
-          <a:noFill/>
-        </p:spPr>
-        <p:txBody>
-          <a:bodyPr wrap="square" lIns="18288" rIns="18288" tIns="9144" bIns="9144">
+            <a:off x="713232" y="2084831"/>
+            <a:ext cx="10515600" cy="502920"/>
+          </a:xfrm>
+          <a:prstGeom prst="rect">
+            <a:avLst/>
+          </a:prstGeom>
+          <a:noFill/>
+        </p:spPr>
+        <p:txBody>
+          <a:bodyPr wrap="square" lIns="36576" rIns="36576" tIns="18288" bIns="18288">
             <a:spAutoFit/>
           </a:bodyPr>
           <a:lstStyle/>
           <a:p>
             <a:pPr>
-              <a:defRPr sz="2000" b="1">
+              <a:defRPr sz="1900" b="1">
                 <a:solidFill>
                   <a:srgbClr val="DCEAE6"/>
                 </a:solidFill>
@@ -5893,7 +7273,7 @@
               </a:defRPr>
             </a:pPr>
             <a:r>
-              <a:t>What we know: software behavior on synthetic fixtures.</a:t>
+              <a:t>KNOWN: software behavior on synthetic fixtures.</a:t>
             </a:r>
           </a:p>
         </p:txBody>
@@ -5906,22 +7286,22 @@
         </p:nvSpPr>
         <p:spPr>
           <a:xfrm>
-            <a:off x="694944" y="2816352"/>
-            <a:ext cx="9875520" cy="502920"/>
-          </a:xfrm>
-          <a:prstGeom prst="rect">
-            <a:avLst/>
-          </a:prstGeom>
-          <a:noFill/>
-        </p:spPr>
-        <p:txBody>
-          <a:bodyPr wrap="square" lIns="18288" rIns="18288" tIns="9144" bIns="9144">
+            <a:off x="713232" y="2770632"/>
+            <a:ext cx="10515600" cy="640080"/>
+          </a:xfrm>
+          <a:prstGeom prst="rect">
+            <a:avLst/>
+          </a:prstGeom>
+          <a:noFill/>
+        </p:spPr>
+        <p:txBody>
+          <a:bodyPr wrap="square" lIns="36576" rIns="36576" tIns="18288" bIns="18288">
             <a:spAutoFit/>
           </a:bodyPr>
           <a:lstStyle/>
           <a:p>
             <a:pPr>
-              <a:defRPr sz="2000" b="1">
+              <a:defRPr sz="1900" b="1">
                 <a:solidFill>
                   <a:srgbClr val="F2D9A8"/>
                 </a:solidFill>
@@ -5929,7 +7309,7 @@
               </a:defRPr>
             </a:pPr>
             <a:r>
-              <a:t>What we do not know: model quality, clinical correctness, or patient impact.</a:t>
+              <a:t>UNKNOWN: model quality, clinical correctness, user outcomes, deployment privacy and retention.</a:t>
             </a:r>
           </a:p>
         </p:txBody>
@@ -5942,16 +7322,16 @@
         </p:nvSpPr>
         <p:spPr>
           <a:xfrm>
-            <a:off x="694944" y="3977639"/>
-            <a:ext cx="9875520" cy="658368"/>
-          </a:xfrm>
-          <a:prstGeom prst="rect">
-            <a:avLst/>
-          </a:prstGeom>
-          <a:noFill/>
-        </p:spPr>
-        <p:txBody>
-          <a:bodyPr wrap="square" lIns="18288" rIns="18288" tIns="9144" bIns="9144">
+            <a:off x="713232" y="3977639"/>
+            <a:ext cx="10332720" cy="594360"/>
+          </a:xfrm>
+          <a:prstGeom prst="rect">
+            <a:avLst/>
+          </a:prstGeom>
+          <a:noFill/>
+        </p:spPr>
+        <p:txBody>
+          <a:bodyPr wrap="square" lIns="36576" rIns="36576" tIns="18288" bIns="18288">
             <a:spAutoFit/>
           </a:bodyPr>
           <a:lstStyle/>
@@ -5978,16 +7358,52 @@
         </p:nvSpPr>
         <p:spPr>
           <a:xfrm>
+            <a:off x="713232" y="4892040"/>
+            <a:ext cx="10332720" cy="274320"/>
+          </a:xfrm>
+          <a:prstGeom prst="rect">
+            <a:avLst/>
+          </a:prstGeom>
+          <a:noFill/>
+        </p:spPr>
+        <p:txBody>
+          <a:bodyPr wrap="square" lIns="36576" rIns="36576" tIns="18288" bIns="18288">
+            <a:spAutoFit/>
+          </a:bodyPr>
+          <a:lstStyle/>
+          <a:p>
+            <a:pPr>
+              <a:defRPr sz="1200" b="1">
+                <a:solidFill>
+                  <a:srgbClr val="BBD7CF"/>
+                </a:solidFill>
+                <a:latin typeface="Aptos"/>
+              </a:defRPr>
+            </a:pPr>
+            <a:r>
+              <a:t>4-minute Q&amp;A</a:t>
+            </a:r>
+          </a:p>
+        </p:txBody>
+      </p:sp>
+      <p:sp>
+        <p:nvSpPr>
+          <p:cNvPr id="8" name="TextBox 7"/>
+          <p:cNvSpPr txBox="1"/>
+          <p:nvPr/>
+        </p:nvSpPr>
+        <p:spPr>
+          <a:xfrm>
             <a:off x="502920" y="6510528"/>
-            <a:ext cx="9601200" cy="164592"/>
-          </a:xfrm>
-          <a:prstGeom prst="rect">
-            <a:avLst/>
-          </a:prstGeom>
-          <a:noFill/>
-        </p:spPr>
-        <p:txBody>
-          <a:bodyPr wrap="square" lIns="18288" rIns="18288" tIns="9144" bIns="9144">
+            <a:ext cx="9692640" cy="164592"/>
+          </a:xfrm>
+          <a:prstGeom prst="rect">
+            <a:avLst/>
+          </a:prstGeom>
+          <a:noFill/>
+        </p:spPr>
+        <p:txBody>
+          <a:bodyPr wrap="square" lIns="36576" rIns="36576" tIns="18288" bIns="18288">
             <a:spAutoFit/>
           </a:bodyPr>
           <a:lstStyle/>
@@ -6001,14 +7417,14 @@
               </a:defRPr>
             </a:pPr>
             <a:r>
-              <a:t>SYNTHETIC-ONLY  |  MODEL DISABLED  |  NOT FOR CLINICAL DECISIONS</a:t>
-            </a:r>
-          </a:p>
-        </p:txBody>
-      </p:sp>
-      <p:sp>
-        <p:nvSpPr>
-          <p:cNvPr id="8" name="TextBox 7"/>
+              <a:t>SYNTHETIC-ONLY  |  MODEL OFF  |  NOT FOR CLINICAL DECISIONS</a:t>
+            </a:r>
+          </a:p>
+        </p:txBody>
+      </p:sp>
+      <p:sp>
+        <p:nvSpPr>
+          <p:cNvPr id="9" name="TextBox 8"/>
           <p:cNvSpPr txBox="1"/>
           <p:nvPr/>
         </p:nvSpPr>
@@ -6023,7 +7439,7 @@
           <a:noFill/>
         </p:spPr>
         <p:txBody>
-          <a:bodyPr wrap="square" lIns="18288" rIns="18288" tIns="9144" bIns="9144">
+          <a:bodyPr wrap="square" lIns="36576" rIns="36576" tIns="18288" bIns="18288">
             <a:spAutoFit/>
           </a:bodyPr>
           <a:lstStyle/>
@@ -6037,7 +7453,7 @@
               </a:defRPr>
             </a:pPr>
             <a:r>
-              <a:t>07</a:t>
+              <a:t>08</a:t>
             </a:r>
           </a:p>
         </p:txBody>

</xml_diff>